<commit_message>
Added and edited slides on missing data impuation
</commit_message>
<xml_diff>
--- a/LectureSlides/11_ModelsForMessyData.pptx
+++ b/LectureSlides/11_ModelsForMessyData.pptx
@@ -5,7 +5,7 @@
     <p:sldMasterId id="2147483648" r:id="rId1"/>
   </p:sldMasterIdLst>
   <p:notesMasterIdLst>
-    <p:notesMasterId r:id="rId70"/>
+    <p:notesMasterId r:id="rId77"/>
   </p:notesMasterIdLst>
   <p:sldIdLst>
     <p:sldId id="337" r:id="rId2"/>
@@ -61,21 +61,28 @@
     <p:sldId id="333" r:id="rId52"/>
     <p:sldId id="367" r:id="rId53"/>
     <p:sldId id="368" r:id="rId54"/>
-    <p:sldId id="386" r:id="rId55"/>
-    <p:sldId id="389" r:id="rId56"/>
-    <p:sldId id="387" r:id="rId57"/>
-    <p:sldId id="388" r:id="rId58"/>
-    <p:sldId id="391" r:id="rId59"/>
-    <p:sldId id="392" r:id="rId60"/>
-    <p:sldId id="390" r:id="rId61"/>
-    <p:sldId id="395" r:id="rId62"/>
-    <p:sldId id="393" r:id="rId63"/>
-    <p:sldId id="396" r:id="rId64"/>
-    <p:sldId id="394" r:id="rId65"/>
-    <p:sldId id="397" r:id="rId66"/>
-    <p:sldId id="398" r:id="rId67"/>
-    <p:sldId id="385" r:id="rId68"/>
-    <p:sldId id="381" r:id="rId69"/>
+    <p:sldId id="403" r:id="rId55"/>
+    <p:sldId id="386" r:id="rId56"/>
+    <p:sldId id="389" r:id="rId57"/>
+    <p:sldId id="387" r:id="rId58"/>
+    <p:sldId id="399" r:id="rId59"/>
+    <p:sldId id="400" r:id="rId60"/>
+    <p:sldId id="404" r:id="rId61"/>
+    <p:sldId id="388" r:id="rId62"/>
+    <p:sldId id="391" r:id="rId63"/>
+    <p:sldId id="392" r:id="rId64"/>
+    <p:sldId id="390" r:id="rId65"/>
+    <p:sldId id="395" r:id="rId66"/>
+    <p:sldId id="393" r:id="rId67"/>
+    <p:sldId id="396" r:id="rId68"/>
+    <p:sldId id="394" r:id="rId69"/>
+    <p:sldId id="397" r:id="rId70"/>
+    <p:sldId id="398" r:id="rId71"/>
+    <p:sldId id="401" r:id="rId72"/>
+    <p:sldId id="405" r:id="rId73"/>
+    <p:sldId id="402" r:id="rId74"/>
+    <p:sldId id="385" r:id="rId75"/>
+    <p:sldId id="381" r:id="rId76"/>
   </p:sldIdLst>
   <p:sldSz cx="9144000" cy="5143500" type="screen16x9"/>
   <p:notesSz cx="6858000" cy="9144000"/>
@@ -275,7 +282,7 @@
           <a:p>
             <a:fld id="{B45A0028-71D2-4800-AD8E-38BD1BCDF688}" type="datetimeFigureOut">
               <a:rPr lang="en-US" smtClean="0"/>
-              <a:t>10/2/2026</a:t>
+              <a:t>10/3/2026</a:t>
             </a:fld>
             <a:endParaRPr lang="en-US"/>
           </a:p>
@@ -805,7 +812,7 @@
           <a:p>
             <a:fld id="{241EB5C9-1307-BA42-ABA2-0BC069CD8E7F}" type="datetimeFigureOut">
               <a:rPr lang="en-US" smtClean="0"/>
-              <a:t>10/2/2026</a:t>
+              <a:t>10/3/2026</a:t>
             </a:fld>
             <a:endParaRPr lang="en-US"/>
           </a:p>
@@ -973,7 +980,7 @@
           <a:p>
             <a:fld id="{241EB5C9-1307-BA42-ABA2-0BC069CD8E7F}" type="datetimeFigureOut">
               <a:rPr lang="en-US" smtClean="0"/>
-              <a:t>10/2/2026</a:t>
+              <a:t>10/3/2026</a:t>
             </a:fld>
             <a:endParaRPr lang="en-US"/>
           </a:p>
@@ -1151,7 +1158,7 @@
           <a:p>
             <a:fld id="{241EB5C9-1307-BA42-ABA2-0BC069CD8E7F}" type="datetimeFigureOut">
               <a:rPr lang="en-US" smtClean="0"/>
-              <a:t>10/2/2026</a:t>
+              <a:t>10/3/2026</a:t>
             </a:fld>
             <a:endParaRPr lang="en-US"/>
           </a:p>
@@ -1319,7 +1326,7 @@
           <a:p>
             <a:fld id="{241EB5C9-1307-BA42-ABA2-0BC069CD8E7F}" type="datetimeFigureOut">
               <a:rPr lang="en-US" smtClean="0"/>
-              <a:t>10/2/2026</a:t>
+              <a:t>10/3/2026</a:t>
             </a:fld>
             <a:endParaRPr lang="en-US"/>
           </a:p>
@@ -1564,7 +1571,7 @@
           <a:p>
             <a:fld id="{241EB5C9-1307-BA42-ABA2-0BC069CD8E7F}" type="datetimeFigureOut">
               <a:rPr lang="en-US" smtClean="0"/>
-              <a:t>10/2/2026</a:t>
+              <a:t>10/3/2026</a:t>
             </a:fld>
             <a:endParaRPr lang="en-US"/>
           </a:p>
@@ -1849,7 +1856,7 @@
           <a:p>
             <a:fld id="{241EB5C9-1307-BA42-ABA2-0BC069CD8E7F}" type="datetimeFigureOut">
               <a:rPr lang="en-US" smtClean="0"/>
-              <a:t>10/2/2026</a:t>
+              <a:t>10/3/2026</a:t>
             </a:fld>
             <a:endParaRPr lang="en-US"/>
           </a:p>
@@ -2268,7 +2275,7 @@
           <a:p>
             <a:fld id="{241EB5C9-1307-BA42-ABA2-0BC069CD8E7F}" type="datetimeFigureOut">
               <a:rPr lang="en-US" smtClean="0"/>
-              <a:t>10/2/2026</a:t>
+              <a:t>10/3/2026</a:t>
             </a:fld>
             <a:endParaRPr lang="en-US"/>
           </a:p>
@@ -2385,7 +2392,7 @@
           <a:p>
             <a:fld id="{241EB5C9-1307-BA42-ABA2-0BC069CD8E7F}" type="datetimeFigureOut">
               <a:rPr lang="en-US" smtClean="0"/>
-              <a:t>10/2/2026</a:t>
+              <a:t>10/3/2026</a:t>
             </a:fld>
             <a:endParaRPr lang="en-US"/>
           </a:p>
@@ -2480,7 +2487,7 @@
           <a:p>
             <a:fld id="{241EB5C9-1307-BA42-ABA2-0BC069CD8E7F}" type="datetimeFigureOut">
               <a:rPr lang="en-US" smtClean="0"/>
-              <a:t>10/2/2026</a:t>
+              <a:t>10/3/2026</a:t>
             </a:fld>
             <a:endParaRPr lang="en-US"/>
           </a:p>
@@ -2755,7 +2762,7 @@
           <a:p>
             <a:fld id="{241EB5C9-1307-BA42-ABA2-0BC069CD8E7F}" type="datetimeFigureOut">
               <a:rPr lang="en-US" smtClean="0"/>
-              <a:t>10/2/2026</a:t>
+              <a:t>10/3/2026</a:t>
             </a:fld>
             <a:endParaRPr lang="en-US"/>
           </a:p>
@@ -3007,7 +3014,7 @@
           <a:p>
             <a:fld id="{241EB5C9-1307-BA42-ABA2-0BC069CD8E7F}" type="datetimeFigureOut">
               <a:rPr lang="en-US" smtClean="0"/>
-              <a:t>10/2/2026</a:t>
+              <a:t>10/3/2026</a:t>
             </a:fld>
             <a:endParaRPr lang="en-US"/>
           </a:p>
@@ -3218,7 +3225,7 @@
           <a:p>
             <a:fld id="{241EB5C9-1307-BA42-ABA2-0BC069CD8E7F}" type="datetimeFigureOut">
               <a:rPr lang="en-US" smtClean="0"/>
-              <a:t>10/2/2026</a:t>
+              <a:t>10/3/2026</a:t>
             </a:fld>
             <a:endParaRPr lang="en-US"/>
           </a:p>
@@ -11523,6 +11530,7 @@
                           <m:ctrlPr>
                             <a:rPr lang="en-US" i="1">
                               <a:latin typeface="Cambria Math" panose="02040503050406030204" pitchFamily="18" charset="0"/>
+                              <a:ea typeface="Cambria Math" panose="02040503050406030204" pitchFamily="18" charset="0"/>
                             </a:rPr>
                           </m:ctrlPr>
                         </m:sSupPr>
@@ -11532,6 +11540,7 @@
                               <m:ctrlPr>
                                 <a:rPr lang="en-US" i="1">
                                   <a:latin typeface="Cambria Math" panose="02040503050406030204" pitchFamily="18" charset="0"/>
+                                  <a:ea typeface="Cambria Math" panose="02040503050406030204" pitchFamily="18" charset="0"/>
                                 </a:rPr>
                               </m:ctrlPr>
                             </m:dPr>
@@ -18842,10 +18851,15 @@
             <p:ph idx="1"/>
           </p:nvPr>
         </p:nvSpPr>
-        <p:spPr/>
+        <p:spPr>
+          <a:xfrm>
+            <a:off x="457200" y="1200151"/>
+            <a:ext cx="8229600" cy="3772902"/>
+          </a:xfrm>
+        </p:spPr>
         <p:txBody>
           <a:bodyPr>
-            <a:normAutofit fontScale="77500" lnSpcReduction="20000"/>
+            <a:normAutofit fontScale="92500" lnSpcReduction="20000"/>
           </a:bodyPr>
           <a:lstStyle/>
           <a:p>
@@ -22594,6 +22608,7 @@
                           <m:ctrlPr>
                             <a:rPr lang="ar-AE" sz="1800" i="1">
                               <a:latin typeface="Cambria Math" panose="02040503050406030204" pitchFamily="18" charset="0"/>
+                              <a:ea typeface="Cambria Math" panose="02040503050406030204" pitchFamily="18" charset="0"/>
                             </a:rPr>
                           </m:ctrlPr>
                         </m:fPr>
@@ -31090,6 +31105,221 @@
         <p:cNvPr id="1" name="">
           <a:extLst>
             <a:ext uri="{FF2B5EF4-FFF2-40B4-BE49-F238E27FC236}">
+              <a16:creationId xmlns:a16="http://schemas.microsoft.com/office/drawing/2014/main" id="{2F3EC160-83A9-5F30-E943-086D24A9DB70}"/>
+            </a:ext>
+          </a:extLst>
+        </p:cNvPr>
+        <p:cNvGrpSpPr/>
+        <p:nvPr/>
+      </p:nvGrpSpPr>
+      <p:grpSpPr>
+        <a:xfrm>
+          <a:off x="0" y="0"/>
+          <a:ext cx="0" cy="0"/>
+          <a:chOff x="0" y="0"/>
+          <a:chExt cx="0" cy="0"/>
+        </a:xfrm>
+      </p:grpSpPr>
+      <p:sp>
+        <p:nvSpPr>
+          <p:cNvPr id="2" name="Title 1">
+            <a:extLst>
+              <a:ext uri="{FF2B5EF4-FFF2-40B4-BE49-F238E27FC236}">
+                <a16:creationId xmlns:a16="http://schemas.microsoft.com/office/drawing/2014/main" id="{75DAC60E-EE1A-7913-8401-689C5F2F588C}"/>
+              </a:ext>
+            </a:extLst>
+          </p:cNvPr>
+          <p:cNvSpPr>
+            <a:spLocks noGrp="1"/>
+          </p:cNvSpPr>
+          <p:nvPr>
+            <p:ph type="title"/>
+          </p:nvPr>
+        </p:nvSpPr>
+        <p:spPr>
+          <a:xfrm>
+            <a:off x="457201" y="204787"/>
+            <a:ext cx="8329352" cy="564140"/>
+          </a:xfrm>
+        </p:spPr>
+        <p:txBody>
+          <a:bodyPr>
+            <a:noAutofit/>
+          </a:bodyPr>
+          <a:lstStyle/>
+          <a:p>
+            <a:pPr marL="0" lvl="0" indent="0" algn="ctr">
+              <a:buNone/>
+            </a:pPr>
+            <a:r>
+              <a:rPr lang="en-US" sz="3200" b="0" dirty="0"/>
+              <a:t>Example: </a:t>
+            </a:r>
+            <a:r>
+              <a:rPr sz="3200" b="0" dirty="0"/>
+              <a:t>Dealing With Outliers</a:t>
+            </a:r>
+          </a:p>
+        </p:txBody>
+      </p:sp>
+      <p:sp>
+        <p:nvSpPr>
+          <p:cNvPr id="4" name="Text Placeholder 3">
+            <a:extLst>
+              <a:ext uri="{FF2B5EF4-FFF2-40B4-BE49-F238E27FC236}">
+                <a16:creationId xmlns:a16="http://schemas.microsoft.com/office/drawing/2014/main" id="{A5514A14-8CB1-4BA9-ECA5-1EEB9A7ABBCC}"/>
+              </a:ext>
+            </a:extLst>
+          </p:cNvPr>
+          <p:cNvSpPr>
+            <a:spLocks noGrp="1"/>
+          </p:cNvSpPr>
+          <p:nvPr>
+            <p:ph type="body" sz="half" idx="2"/>
+          </p:nvPr>
+        </p:nvSpPr>
+        <p:spPr>
+          <a:xfrm>
+            <a:off x="457201" y="1076326"/>
+            <a:ext cx="7930341" cy="3518297"/>
+          </a:xfrm>
+        </p:spPr>
+        <p:txBody>
+          <a:bodyPr>
+            <a:normAutofit fontScale="92500" lnSpcReduction="10000"/>
+          </a:bodyPr>
+          <a:lstStyle/>
+          <a:p>
+            <a:pPr marL="0" lvl="0" indent="0">
+              <a:buNone/>
+            </a:pPr>
+            <a:r>
+              <a:rPr lang="en-US" sz="2800" dirty="0"/>
+              <a:t>For further reading on robust statistical models</a:t>
+            </a:r>
+          </a:p>
+          <a:p>
+            <a:pPr marL="457200" lvl="0" indent="-457200">
+              <a:buFont typeface="Arial" panose="020B0604020202020204" pitchFamily="34" charset="0"/>
+              <a:buChar char="•"/>
+            </a:pPr>
+            <a:r>
+              <a:rPr lang="en-US" sz="2800" dirty="0"/>
+              <a:t>For an up to date broad and deep treatment of theory and practical use of robust models see </a:t>
+            </a:r>
+            <a:r>
+              <a:rPr lang="en-US" sz="2800" dirty="0">
+                <a:hlinkClick r:id="rId2"/>
+              </a:rPr>
+              <a:t>Robust Statistics, Theory and Methods (with R), Second Edition, </a:t>
+            </a:r>
+            <a:r>
+              <a:rPr lang="en-US" sz="2800" dirty="0" err="1">
+                <a:hlinkClick r:id="rId2"/>
+              </a:rPr>
+              <a:t>Maronna</a:t>
+            </a:r>
+            <a:r>
+              <a:rPr lang="en-US" sz="2800" dirty="0">
+                <a:hlinkClick r:id="rId2"/>
+              </a:rPr>
+              <a:t>, Martin, Yohai, </a:t>
+            </a:r>
+            <a:r>
+              <a:rPr lang="en-US" sz="2800" dirty="0" err="1">
+                <a:hlinkClick r:id="rId2"/>
+              </a:rPr>
+              <a:t>Salibian</a:t>
+            </a:r>
+            <a:r>
+              <a:rPr lang="en-US" sz="2800" dirty="0">
+                <a:hlinkClick r:id="rId2"/>
+              </a:rPr>
+              <a:t>-Barrera, Wiley, 2019</a:t>
+            </a:r>
+            <a:r>
+              <a:rPr lang="en-US" sz="2800" dirty="0"/>
+              <a:t>      </a:t>
+            </a:r>
+          </a:p>
+          <a:p>
+            <a:pPr marL="457200" lvl="0" indent="-457200">
+              <a:buFont typeface="Arial" panose="020B0604020202020204" pitchFamily="34" charset="0"/>
+              <a:buChar char="•"/>
+            </a:pPr>
+            <a:r>
+              <a:rPr lang="en-US" sz="2800" dirty="0"/>
+              <a:t>The classic treatment of this subject is Robust Statistics, </a:t>
+            </a:r>
+            <a:r>
+              <a:rPr lang="en-US" sz="2800" dirty="0">
+                <a:hlinkClick r:id="rId3"/>
+              </a:rPr>
+              <a:t>The Approach Based on Influence Functions, Hample, </a:t>
+            </a:r>
+            <a:r>
+              <a:rPr lang="en-US" sz="2800" dirty="0" err="1">
+                <a:hlinkClick r:id="rId3"/>
+              </a:rPr>
+              <a:t>Rousseeuw</a:t>
+            </a:r>
+            <a:r>
+              <a:rPr lang="en-US" sz="2800" dirty="0">
+                <a:hlinkClick r:id="rId3"/>
+              </a:rPr>
+              <a:t>, Ronchetti, Stahel, </a:t>
+            </a:r>
+            <a:r>
+              <a:rPr lang="en-US" sz="2800" dirty="0" err="1">
+                <a:hlinkClick r:id="rId3"/>
+              </a:rPr>
+              <a:t>Weily</a:t>
+            </a:r>
+            <a:r>
+              <a:rPr lang="en-US" sz="2800" dirty="0">
+                <a:hlinkClick r:id="rId3"/>
+              </a:rPr>
+              <a:t>, 1986</a:t>
+            </a:r>
+            <a:endParaRPr lang="en-US" sz="2800" dirty="0"/>
+          </a:p>
+          <a:p>
+            <a:pPr marL="457200" lvl="0" indent="-457200">
+              <a:buFont typeface="Arial" panose="020B0604020202020204" pitchFamily="34" charset="0"/>
+              <a:buChar char="•"/>
+            </a:pPr>
+            <a:endParaRPr lang="en-US" sz="2800" dirty="0"/>
+          </a:p>
+          <a:p>
+            <a:pPr marL="457200" lvl="0" indent="-457200">
+              <a:buFont typeface="Arial" panose="020B0604020202020204" pitchFamily="34" charset="0"/>
+              <a:buChar char="•"/>
+            </a:pPr>
+            <a:endParaRPr sz="2800" dirty="0"/>
+          </a:p>
+        </p:txBody>
+      </p:sp>
+    </p:spTree>
+    <p:extLst>
+      <p:ext uri="{BB962C8B-B14F-4D97-AF65-F5344CB8AC3E}">
+        <p14:creationId xmlns:p14="http://schemas.microsoft.com/office/powerpoint/2010/main" val="673293599"/>
+      </p:ext>
+    </p:extLst>
+  </p:cSld>
+  <p:clrMapOvr>
+    <a:masterClrMapping/>
+  </p:clrMapOvr>
+</p:sld>
+</file>
+
+<file path=ppt/slides/slide55.xml><?xml version="1.0" encoding="utf-8"?>
+<p:sld xmlns:a="http://schemas.openxmlformats.org/drawingml/2006/main" xmlns:r="http://schemas.openxmlformats.org/officeDocument/2006/relationships" xmlns:p="http://schemas.openxmlformats.org/presentationml/2006/main">
+  <p:cSld>
+    <p:spTree>
+      <p:nvGrpSpPr>
+        <p:cNvPr id="1" name="">
+          <a:extLst>
+            <a:ext uri="{FF2B5EF4-FFF2-40B4-BE49-F238E27FC236}">
               <a16:creationId xmlns:a16="http://schemas.microsoft.com/office/drawing/2014/main" id="{E8000A26-C1B1-F422-3D2C-56EDC696E9A1}"/>
             </a:ext>
           </a:extLst>
@@ -31152,7 +31382,7 @@
 </p:sld>
 </file>
 
-<file path=ppt/slides/slide55.xml><?xml version="1.0" encoding="utf-8"?>
+<file path=ppt/slides/slide56.xml><?xml version="1.0" encoding="utf-8"?>
 <p:sld xmlns:a="http://schemas.openxmlformats.org/drawingml/2006/main" xmlns:r="http://schemas.openxmlformats.org/officeDocument/2006/relationships" xmlns:p="http://schemas.openxmlformats.org/presentationml/2006/main">
   <p:cSld>
     <p:spTree>
@@ -31309,7 +31539,7 @@
 </p:sld>
 </file>
 
-<file path=ppt/slides/slide56.xml><?xml version="1.0" encoding="utf-8"?>
+<file path=ppt/slides/slide57.xml><?xml version="1.0" encoding="utf-8"?>
 <p:sld xmlns:a="http://schemas.openxmlformats.org/drawingml/2006/main" xmlns:r="http://schemas.openxmlformats.org/officeDocument/2006/relationships" xmlns:p="http://schemas.openxmlformats.org/presentationml/2006/main">
   <p:cSld>
     <p:spTree>
@@ -31444,7 +31674,7 @@
 </p:sld>
 </file>
 
-<file path=ppt/slides/slide57.xml><?xml version="1.0" encoding="utf-8"?>
+<file path=ppt/slides/slide58.xml><?xml version="1.0" encoding="utf-8"?>
 <p:sld xmlns:a="http://schemas.openxmlformats.org/drawingml/2006/main" xmlns:r="http://schemas.openxmlformats.org/officeDocument/2006/relationships" xmlns:p="http://schemas.openxmlformats.org/presentationml/2006/main">
   <p:cSld>
     <p:spTree>
@@ -31452,7 +31682,7 @@
         <p:cNvPr id="1" name="">
           <a:extLst>
             <a:ext uri="{FF2B5EF4-FFF2-40B4-BE49-F238E27FC236}">
-              <a16:creationId xmlns:a16="http://schemas.microsoft.com/office/drawing/2014/main" id="{7169A6A7-2558-E14C-937F-76133ACABB72}"/>
+              <a16:creationId xmlns:a16="http://schemas.microsoft.com/office/drawing/2014/main" id="{DA02ECB3-6BBE-DCFD-B036-32887A538AC9}"/>
             </a:ext>
           </a:extLst>
         </p:cNvPr>
@@ -31472,7 +31702,7 @@
           <p:cNvPr id="2" name="Title 1">
             <a:extLst>
               <a:ext uri="{FF2B5EF4-FFF2-40B4-BE49-F238E27FC236}">
-                <a16:creationId xmlns:a16="http://schemas.microsoft.com/office/drawing/2014/main" id="{A919FC23-6B25-1B58-E331-78BC2B52991B}"/>
+                <a16:creationId xmlns:a16="http://schemas.microsoft.com/office/drawing/2014/main" id="{6DD8DEE9-EFE3-5E17-CBBA-D4D63BA5D13C}"/>
               </a:ext>
             </a:extLst>
           </p:cNvPr>
@@ -31493,7 +31723,7 @@
             </a:pPr>
             <a:r>
               <a:rPr lang="en-US" dirty="0"/>
-              <a:t>Imputation of Missing Values</a:t>
+              <a:t>Understanding Missing Values</a:t>
             </a:r>
             <a:endParaRPr dirty="0"/>
           </a:p>
@@ -31504,7 +31734,7 @@
           <p:cNvPr id="3" name="Content Placeholder 2">
             <a:extLst>
               <a:ext uri="{FF2B5EF4-FFF2-40B4-BE49-F238E27FC236}">
-                <a16:creationId xmlns:a16="http://schemas.microsoft.com/office/drawing/2014/main" id="{C310ECD3-6581-1420-5CE3-136248DB3BEE}"/>
+                <a16:creationId xmlns:a16="http://schemas.microsoft.com/office/drawing/2014/main" id="{C5512292-9EC6-85A5-8689-82BEEAD3493E}"/>
               </a:ext>
             </a:extLst>
           </p:cNvPr>
@@ -31517,8 +31747,8 @@
         </p:nvSpPr>
         <p:spPr>
           <a:xfrm>
-            <a:off x="457200" y="1200151"/>
-            <a:ext cx="8229600" cy="3737370"/>
+            <a:off x="429610" y="924711"/>
+            <a:ext cx="8229600" cy="510408"/>
           </a:xfrm>
         </p:spPr>
         <p:txBody>
@@ -31532,44 +31762,229 @@
             </a:pPr>
             <a:r>
               <a:rPr lang="en-US" dirty="0"/>
-              <a:t>Imputation methods must match the missing data pattern and intended use</a:t>
-            </a:r>
-          </a:p>
+              <a:t>Exploring missing data patterns </a:t>
+            </a:r>
+          </a:p>
+        </p:txBody>
+      </p:sp>
+      <p:pic>
+        <p:nvPicPr>
+          <p:cNvPr id="6" name="Picture 5">
+            <a:extLst>
+              <a:ext uri="{FF2B5EF4-FFF2-40B4-BE49-F238E27FC236}">
+                <a16:creationId xmlns:a16="http://schemas.microsoft.com/office/drawing/2014/main" id="{EB6F8BBD-102D-4477-D7E5-A856650979A0}"/>
+              </a:ext>
+            </a:extLst>
+          </p:cNvPr>
+          <p:cNvPicPr>
+            <a:picLocks noChangeAspect="1"/>
+          </p:cNvPicPr>
+          <p:nvPr/>
+        </p:nvPicPr>
+        <p:blipFill>
+          <a:blip r:embed="rId2"/>
+          <a:stretch>
+            <a:fillRect/>
+          </a:stretch>
+        </p:blipFill>
+        <p:spPr>
+          <a:xfrm>
+            <a:off x="3565027" y="1730266"/>
+            <a:ext cx="5578973" cy="2982102"/>
+          </a:xfrm>
+          <a:prstGeom prst="rect">
+            <a:avLst/>
+          </a:prstGeom>
+        </p:spPr>
+      </p:pic>
+      <p:sp>
+        <p:nvSpPr>
+          <p:cNvPr id="7" name="Content Placeholder 2">
+            <a:extLst>
+              <a:ext uri="{FF2B5EF4-FFF2-40B4-BE49-F238E27FC236}">
+                <a16:creationId xmlns:a16="http://schemas.microsoft.com/office/drawing/2014/main" id="{0D483E30-C1C6-1F1B-F030-57B9C64F5F97}"/>
+              </a:ext>
+            </a:extLst>
+          </p:cNvPr>
+          <p:cNvSpPr txBox="1">
+            <a:spLocks/>
+          </p:cNvSpPr>
+          <p:nvPr/>
+        </p:nvSpPr>
+        <p:spPr>
+          <a:xfrm>
+            <a:off x="457200" y="1399674"/>
+            <a:ext cx="3007895" cy="3621505"/>
+          </a:xfrm>
+          <a:prstGeom prst="rect">
+            <a:avLst/>
+          </a:prstGeom>
+        </p:spPr>
+        <p:txBody>
+          <a:bodyPr vert="horz" lIns="91440" tIns="45720" rIns="91440" bIns="45720" rtlCol="0">
+            <a:normAutofit/>
+          </a:bodyPr>
+          <a:lstStyle>
+            <a:lvl1pPr marL="342900" indent="-342900" algn="l" defTabSz="342900" rtl="0" eaLnBrk="1" latinLnBrk="0" hangingPunct="1">
+              <a:spcBef>
+                <a:spcPct val="20000"/>
+              </a:spcBef>
+              <a:buFont typeface="Arial"/>
+              <a:buChar char="•"/>
+              <a:defRPr sz="2400" kern="1200">
+                <a:solidFill>
+                  <a:schemeClr val="tx1"/>
+                </a:solidFill>
+                <a:latin typeface="+mn-lt"/>
+                <a:ea typeface="+mn-ea"/>
+                <a:cs typeface="+mn-cs"/>
+              </a:defRPr>
+            </a:lvl1pPr>
+            <a:lvl2pPr marL="685800" indent="-342900" algn="l" defTabSz="342900" rtl="0" eaLnBrk="1" latinLnBrk="0" hangingPunct="1">
+              <a:spcBef>
+                <a:spcPct val="20000"/>
+              </a:spcBef>
+              <a:buFont typeface="Arial"/>
+              <a:buChar char="–"/>
+              <a:defRPr sz="2100" kern="1200">
+                <a:solidFill>
+                  <a:schemeClr val="tx1"/>
+                </a:solidFill>
+                <a:latin typeface="+mn-lt"/>
+                <a:ea typeface="+mn-ea"/>
+                <a:cs typeface="+mn-cs"/>
+              </a:defRPr>
+            </a:lvl2pPr>
+            <a:lvl3pPr marL="1028700" indent="-342900" algn="l" defTabSz="342900" rtl="0" eaLnBrk="1" latinLnBrk="0" hangingPunct="1">
+              <a:spcBef>
+                <a:spcPct val="20000"/>
+              </a:spcBef>
+              <a:buFont typeface="Arial"/>
+              <a:buChar char="•"/>
+              <a:defRPr sz="1800" kern="1200">
+                <a:solidFill>
+                  <a:schemeClr val="tx1"/>
+                </a:solidFill>
+                <a:latin typeface="+mn-lt"/>
+                <a:ea typeface="+mn-ea"/>
+                <a:cs typeface="+mn-cs"/>
+              </a:defRPr>
+            </a:lvl3pPr>
+            <a:lvl4pPr marL="1371600" indent="-342900" algn="l" defTabSz="342900" rtl="0" eaLnBrk="1" latinLnBrk="0" hangingPunct="1">
+              <a:spcBef>
+                <a:spcPct val="20000"/>
+              </a:spcBef>
+              <a:buFont typeface="Arial"/>
+              <a:buChar char="–"/>
+              <a:defRPr sz="1500" kern="1200">
+                <a:solidFill>
+                  <a:schemeClr val="tx1"/>
+                </a:solidFill>
+                <a:latin typeface="+mn-lt"/>
+                <a:ea typeface="+mn-ea"/>
+                <a:cs typeface="+mn-cs"/>
+              </a:defRPr>
+            </a:lvl4pPr>
+            <a:lvl5pPr marL="1714500" indent="-342900" algn="l" defTabSz="342900" rtl="0" eaLnBrk="1" latinLnBrk="0" hangingPunct="1">
+              <a:spcBef>
+                <a:spcPct val="20000"/>
+              </a:spcBef>
+              <a:buFont typeface="Arial"/>
+              <a:buChar char="»"/>
+              <a:defRPr sz="1500" kern="1200">
+                <a:solidFill>
+                  <a:schemeClr val="tx1"/>
+                </a:solidFill>
+                <a:latin typeface="+mn-lt"/>
+                <a:ea typeface="+mn-ea"/>
+                <a:cs typeface="+mn-cs"/>
+              </a:defRPr>
+            </a:lvl5pPr>
+            <a:lvl6pPr marL="2057400" indent="-342900" algn="l" defTabSz="342900" rtl="0" eaLnBrk="1" latinLnBrk="0" hangingPunct="1">
+              <a:spcBef>
+                <a:spcPct val="20000"/>
+              </a:spcBef>
+              <a:buFont typeface="Arial"/>
+              <a:buChar char="•"/>
+              <a:defRPr sz="1500" kern="1200">
+                <a:solidFill>
+                  <a:schemeClr val="tx1"/>
+                </a:solidFill>
+                <a:latin typeface="+mn-lt"/>
+                <a:ea typeface="+mn-ea"/>
+                <a:cs typeface="+mn-cs"/>
+              </a:defRPr>
+            </a:lvl6pPr>
+            <a:lvl7pPr marL="2400300" indent="-342900" algn="l" defTabSz="342900" rtl="0" eaLnBrk="1" latinLnBrk="0" hangingPunct="1">
+              <a:spcBef>
+                <a:spcPct val="20000"/>
+              </a:spcBef>
+              <a:buFont typeface="Arial"/>
+              <a:buChar char="•"/>
+              <a:defRPr sz="1500" kern="1200">
+                <a:solidFill>
+                  <a:schemeClr val="tx1"/>
+                </a:solidFill>
+                <a:latin typeface="+mn-lt"/>
+                <a:ea typeface="+mn-ea"/>
+                <a:cs typeface="+mn-cs"/>
+              </a:defRPr>
+            </a:lvl7pPr>
+            <a:lvl8pPr marL="2743200" indent="-342900" algn="l" defTabSz="342900" rtl="0" eaLnBrk="1" latinLnBrk="0" hangingPunct="1">
+              <a:spcBef>
+                <a:spcPct val="20000"/>
+              </a:spcBef>
+              <a:buFont typeface="Arial"/>
+              <a:buChar char="•"/>
+              <a:defRPr sz="1500" kern="1200">
+                <a:solidFill>
+                  <a:schemeClr val="tx1"/>
+                </a:solidFill>
+                <a:latin typeface="+mn-lt"/>
+                <a:ea typeface="+mn-ea"/>
+                <a:cs typeface="+mn-cs"/>
+              </a:defRPr>
+            </a:lvl8pPr>
+            <a:lvl9pPr marL="3086100" indent="-342900" algn="l" defTabSz="342900" rtl="0" eaLnBrk="1" latinLnBrk="0" hangingPunct="1">
+              <a:spcBef>
+                <a:spcPct val="20000"/>
+              </a:spcBef>
+              <a:buFont typeface="Arial"/>
+              <a:buChar char="•"/>
+              <a:defRPr sz="1500" kern="1200">
+                <a:solidFill>
+                  <a:schemeClr val="tx1"/>
+                </a:solidFill>
+                <a:latin typeface="+mn-lt"/>
+                <a:ea typeface="+mn-ea"/>
+                <a:cs typeface="+mn-cs"/>
+              </a:defRPr>
+            </a:lvl9pPr>
+          </a:lstStyle>
           <a:p>
             <a:r>
               <a:rPr lang="en-US" dirty="0"/>
-              <a:t>Machine learning algorithms only need a good point estimate for the imputed value</a:t>
-            </a:r>
-          </a:p>
-          <a:p>
-            <a:pPr lvl="1"/>
+              <a:t>Plot reveals missing value pattern in variables by row         </a:t>
+            </a:r>
+          </a:p>
+          <a:p>
             <a:r>
               <a:rPr lang="en-US" dirty="0"/>
-              <a:t>For ML, we do not much care what the confidence intervals are</a:t>
+              <a:t>Some rows have only one missing value</a:t>
             </a:r>
           </a:p>
           <a:p>
             <a:r>
               <a:rPr lang="en-US" dirty="0"/>
-              <a:t>Inference requires drawing imputed values from the distribution of the variable  </a:t>
-            </a:r>
-          </a:p>
-          <a:p>
-            <a:pPr lvl="1"/>
-            <a:r>
-              <a:rPr lang="en-US" dirty="0"/>
-              <a:t>We want unbiased estimates of the confidence intervals  </a:t>
-            </a:r>
-          </a:p>
-          <a:p>
-            <a:endParaRPr dirty="0"/>
+              <a:t>Other rows have multiple missing values  </a:t>
+            </a:r>
           </a:p>
         </p:txBody>
       </p:sp>
     </p:spTree>
     <p:extLst>
       <p:ext uri="{BB962C8B-B14F-4D97-AF65-F5344CB8AC3E}">
-        <p14:creationId xmlns:p14="http://schemas.microsoft.com/office/powerpoint/2010/main" val="1833434833"/>
+        <p14:creationId xmlns:p14="http://schemas.microsoft.com/office/powerpoint/2010/main" val="3028361265"/>
       </p:ext>
     </p:extLst>
   </p:cSld>
@@ -31579,7 +31994,7 @@
 </p:sld>
 </file>
 
-<file path=ppt/slides/slide58.xml><?xml version="1.0" encoding="utf-8"?>
+<file path=ppt/slides/slide59.xml><?xml version="1.0" encoding="utf-8"?>
 <p:sld xmlns:a="http://schemas.openxmlformats.org/drawingml/2006/main" xmlns:r="http://schemas.openxmlformats.org/officeDocument/2006/relationships" xmlns:p="http://schemas.openxmlformats.org/presentationml/2006/main">
   <p:cSld>
     <p:spTree>
@@ -31587,7 +32002,7 @@
         <p:cNvPr id="1" name="">
           <a:extLst>
             <a:ext uri="{FF2B5EF4-FFF2-40B4-BE49-F238E27FC236}">
-              <a16:creationId xmlns:a16="http://schemas.microsoft.com/office/drawing/2014/main" id="{CE1DAB7D-6678-A6DC-17E0-2F2C67358EC1}"/>
+              <a16:creationId xmlns:a16="http://schemas.microsoft.com/office/drawing/2014/main" id="{3D44FDFC-4F69-DFB8-A2BC-CF8EB3C07576}"/>
             </a:ext>
           </a:extLst>
         </p:cNvPr>
@@ -31607,7 +32022,7 @@
           <p:cNvPr id="2" name="Title 1">
             <a:extLst>
               <a:ext uri="{FF2B5EF4-FFF2-40B4-BE49-F238E27FC236}">
-                <a16:creationId xmlns:a16="http://schemas.microsoft.com/office/drawing/2014/main" id="{52A1E7A9-8462-AFB6-69E8-D29C815D4DD0}"/>
+                <a16:creationId xmlns:a16="http://schemas.microsoft.com/office/drawing/2014/main" id="{91A30F1C-4589-D04C-A165-DD3A86E76EE2}"/>
               </a:ext>
             </a:extLst>
           </p:cNvPr>
@@ -31628,257 +32043,253 @@
             </a:pPr>
             <a:r>
               <a:rPr lang="en-US" dirty="0"/>
-              <a:t>Imputation of Missing Values</a:t>
+              <a:t>Understanding Missing Values</a:t>
             </a:r>
             <a:endParaRPr dirty="0"/>
           </a:p>
         </p:txBody>
       </p:sp>
-      <p:sp>
-        <p:nvSpPr>
-          <p:cNvPr id="3" name="Content Placeholder 2">
-            <a:extLst>
-              <a:ext uri="{FF2B5EF4-FFF2-40B4-BE49-F238E27FC236}">
-                <a16:creationId xmlns:a16="http://schemas.microsoft.com/office/drawing/2014/main" id="{EE8C0F07-8E21-F467-CD9D-1ED0C942B535}"/>
-              </a:ext>
-            </a:extLst>
-          </p:cNvPr>
-          <p:cNvSpPr>
-            <a:spLocks noGrp="1"/>
-          </p:cNvSpPr>
-          <p:nvPr>
-            <p:ph idx="1"/>
-          </p:nvPr>
-        </p:nvSpPr>
-        <p:spPr>
-          <a:xfrm>
-            <a:off x="457200" y="1200151"/>
-            <a:ext cx="8229600" cy="3737370"/>
-          </a:xfrm>
-        </p:spPr>
-        <p:txBody>
-          <a:bodyPr>
-            <a:normAutofit lnSpcReduction="10000"/>
-          </a:bodyPr>
-          <a:lstStyle/>
-          <a:p>
-            <a:pPr marL="0" lvl="0" indent="0">
-              <a:buNone/>
-            </a:pPr>
-            <a:r>
-              <a:rPr lang="en-US" dirty="0"/>
-              <a:t>Algorithms used for MCAR and MAR data for machine learning do not need to preserve distributions</a:t>
-            </a:r>
-          </a:p>
-          <a:p>
-            <a:r>
-              <a:rPr lang="en-US" dirty="0"/>
-              <a:t>Commonly used algorithms for machine </a:t>
-            </a:r>
-            <a:r>
-              <a:rPr lang="en-US" dirty="0" err="1"/>
-              <a:t>learling</a:t>
-            </a:r>
-            <a:r>
-              <a:rPr lang="en-US" dirty="0"/>
-              <a:t> include</a:t>
-            </a:r>
-          </a:p>
-          <a:p>
-            <a:pPr lvl="1"/>
-            <a:r>
-              <a:rPr lang="en-US" dirty="0"/>
-              <a:t>Filling, mean, median, …</a:t>
-            </a:r>
-          </a:p>
-          <a:p>
-            <a:pPr lvl="1"/>
-            <a:r>
-              <a:rPr lang="en-US" dirty="0"/>
-              <a:t>Interpolation, linear, spline, etc.     </a:t>
-            </a:r>
-          </a:p>
-          <a:p>
-            <a:pPr lvl="1"/>
-            <a:r>
-              <a:rPr lang="en-US" dirty="0"/>
-              <a:t>Forward and back filling</a:t>
-            </a:r>
-          </a:p>
-          <a:p>
-            <a:pPr lvl="1"/>
-            <a:r>
-              <a:rPr lang="en-US" dirty="0"/>
-              <a:t>K-nearest neighbors </a:t>
-            </a:r>
-          </a:p>
-          <a:p>
-            <a:pPr lvl="1"/>
-            <a:r>
-              <a:rPr lang="en-US" dirty="0" err="1"/>
-              <a:t>etc</a:t>
-            </a:r>
-            <a:r>
-              <a:rPr lang="en-US" dirty="0"/>
-              <a:t>… </a:t>
-            </a:r>
-          </a:p>
-          <a:p>
-            <a:r>
-              <a:rPr lang="en-US" dirty="0"/>
-              <a:t>These algorithms only provide point estimates and are not useful for inference   </a:t>
-            </a:r>
-          </a:p>
-          <a:p>
-            <a:endParaRPr dirty="0"/>
-          </a:p>
-        </p:txBody>
-      </p:sp>
+      <mc:AlternateContent xmlns:mc="http://schemas.openxmlformats.org/markup-compatibility/2006" xmlns:a14="http://schemas.microsoft.com/office/drawing/2010/main">
+        <mc:Choice Requires="a14">
+          <p:sp>
+            <p:nvSpPr>
+              <p:cNvPr id="3" name="Content Placeholder 2">
+                <a:extLst>
+                  <a:ext uri="{FF2B5EF4-FFF2-40B4-BE49-F238E27FC236}">
+                    <a16:creationId xmlns:a16="http://schemas.microsoft.com/office/drawing/2014/main" id="{94599B7E-B879-000C-DCA7-404F6FA7D88B}"/>
+                  </a:ext>
+                </a:extLst>
+              </p:cNvPr>
+              <p:cNvSpPr>
+                <a:spLocks noGrp="1"/>
+              </p:cNvSpPr>
+              <p:nvPr>
+                <p:ph idx="1"/>
+              </p:nvPr>
+            </p:nvSpPr>
+            <p:spPr>
+              <a:xfrm>
+                <a:off x="457200" y="1200151"/>
+                <a:ext cx="8229600" cy="3737370"/>
+              </a:xfrm>
+            </p:spPr>
+            <p:txBody>
+              <a:bodyPr>
+                <a:normAutofit lnSpcReduction="10000"/>
+              </a:bodyPr>
+              <a:lstStyle/>
+              <a:p>
+                <a:pPr marL="0" lvl="0" indent="0">
+                  <a:buNone/>
+                </a:pPr>
+                <a:r>
+                  <a:rPr lang="en-US" dirty="0"/>
+                  <a:t>We can use </a:t>
+                </a:r>
+                <a:r>
+                  <a:rPr lang="en-US" b="1" dirty="0"/>
+                  <a:t>Little’s MCAR test </a:t>
+                </a:r>
+                <a:r>
+                  <a:rPr lang="en-US" dirty="0"/>
+                  <a:t>to support a hypothesis of a missing pattern</a:t>
+                </a:r>
+              </a:p>
+              <a:p>
+                <a:r>
+                  <a:rPr lang="en-US" b="1" dirty="0"/>
+                  <a:t>Test Statistic: </a:t>
+                </a:r>
+                <a:r>
+                  <a:rPr lang="en-US" dirty="0"/>
+                  <a:t>Observed means across different missing data patterns with expected population means are chi-square (χ²) distributed </a:t>
+                </a:r>
+              </a:p>
+              <a:p>
+                <a:pPr lvl="0"/>
+                <a:r>
+                  <a:rPr lang="en-US" b="1" dirty="0"/>
+                  <a:t>Null Hypothesis </a:t>
+                </a:r>
+                <a14:m>
+                  <m:oMath xmlns:m="http://schemas.openxmlformats.org/officeDocument/2006/math">
+                    <m:d>
+                      <m:dPr>
+                        <m:ctrlPr>
+                          <a:rPr lang="en-US" b="1" i="1" smtClean="0">
+                            <a:latin typeface="Cambria Math" panose="02040503050406030204" pitchFamily="18" charset="0"/>
+                          </a:rPr>
+                        </m:ctrlPr>
+                      </m:dPr>
+                      <m:e>
+                        <m:sSub>
+                          <m:sSubPr>
+                            <m:ctrlPr>
+                              <a:rPr lang="en-US" b="1" i="1" smtClean="0">
+                                <a:latin typeface="Cambria Math" panose="02040503050406030204" pitchFamily="18" charset="0"/>
+                              </a:rPr>
+                            </m:ctrlPr>
+                          </m:sSubPr>
+                          <m:e>
+                            <m:r>
+                              <a:rPr lang="en-US" b="1" i="1" smtClean="0">
+                                <a:latin typeface="Cambria Math" panose="02040503050406030204" pitchFamily="18" charset="0"/>
+                              </a:rPr>
+                              <m:t>𝑯</m:t>
+                            </m:r>
+                          </m:e>
+                          <m:sub>
+                            <m:r>
+                              <a:rPr lang="en-US" b="1" i="1" smtClean="0">
+                                <a:latin typeface="Cambria Math" panose="02040503050406030204" pitchFamily="18" charset="0"/>
+                              </a:rPr>
+                              <m:t>𝟎</m:t>
+                            </m:r>
+                          </m:sub>
+                        </m:sSub>
+                      </m:e>
+                    </m:d>
+                  </m:oMath>
+                </a14:m>
+                <a:r>
+                  <a:rPr lang="en-US" b="1" dirty="0"/>
+                  <a:t>:</a:t>
+                </a:r>
+                <a:r>
+                  <a:rPr lang="en-US" dirty="0"/>
+                  <a:t> The data are Missing Completely at Random</a:t>
+                </a:r>
+              </a:p>
+              <a:p>
+                <a:pPr lvl="1"/>
+                <a:r>
+                  <a:rPr lang="en-US" dirty="0"/>
+                  <a:t>The missing values do not depend on the data values)</a:t>
+                </a:r>
+              </a:p>
+              <a:p>
+                <a:pPr lvl="1"/>
+                <a:r>
+                  <a:rPr lang="en-US" b="1" dirty="0"/>
+                  <a:t>Alternative Hypothesis </a:t>
+                </a:r>
+                <a14:m>
+                  <m:oMath xmlns:m="http://schemas.openxmlformats.org/officeDocument/2006/math">
+                    <m:d>
+                      <m:dPr>
+                        <m:ctrlPr>
+                          <a:rPr lang="en-US" b="1" i="1">
+                            <a:latin typeface="Cambria Math" panose="02040503050406030204" pitchFamily="18" charset="0"/>
+                          </a:rPr>
+                        </m:ctrlPr>
+                      </m:dPr>
+                      <m:e>
+                        <m:sSub>
+                          <m:sSubPr>
+                            <m:ctrlPr>
+                              <a:rPr lang="en-US" b="1" i="1">
+                                <a:latin typeface="Cambria Math" panose="02040503050406030204" pitchFamily="18" charset="0"/>
+                              </a:rPr>
+                            </m:ctrlPr>
+                          </m:sSubPr>
+                          <m:e>
+                            <m:r>
+                              <a:rPr lang="en-US" b="1" i="1">
+                                <a:latin typeface="Cambria Math" panose="02040503050406030204" pitchFamily="18" charset="0"/>
+                              </a:rPr>
+                              <m:t>𝑯</m:t>
+                            </m:r>
+                          </m:e>
+                          <m:sub>
+                            <m:r>
+                              <a:rPr lang="en-US" b="1" i="1" smtClean="0">
+                                <a:latin typeface="Cambria Math" panose="02040503050406030204" pitchFamily="18" charset="0"/>
+                              </a:rPr>
+                              <m:t>𝒂</m:t>
+                            </m:r>
+                          </m:sub>
+                        </m:sSub>
+                      </m:e>
+                    </m:d>
+                    <m:r>
+                      <a:rPr lang="en-US" b="1" i="1">
+                        <a:latin typeface="Cambria Math" panose="02040503050406030204" pitchFamily="18" charset="0"/>
+                      </a:rPr>
+                      <m:t> </m:t>
+                    </m:r>
+                  </m:oMath>
+                </a14:m>
+                <a:r>
+                  <a:rPr lang="en-US" b="1" dirty="0"/>
+                  <a:t>:</a:t>
+                </a:r>
+                <a:r>
+                  <a:rPr lang="en-US" dirty="0"/>
+                  <a:t> Data are </a:t>
+                </a:r>
+                <a:r>
+                  <a:rPr lang="en-US" i="1" dirty="0"/>
+                  <a:t>not</a:t>
+                </a:r>
+                <a:r>
+                  <a:rPr lang="en-US" dirty="0"/>
+                  <a:t> Missing Completely at Random</a:t>
+                </a:r>
+              </a:p>
+              <a:p>
+                <a:endParaRPr dirty="0"/>
+              </a:p>
+            </p:txBody>
+          </p:sp>
+        </mc:Choice>
+        <mc:Fallback xmlns="">
+          <p:sp>
+            <p:nvSpPr>
+              <p:cNvPr id="3" name="Content Placeholder 2">
+                <a:extLst>
+                  <a:ext uri="{FF2B5EF4-FFF2-40B4-BE49-F238E27FC236}">
+                    <a16:creationId xmlns:a16="http://schemas.microsoft.com/office/drawing/2014/main" id="{94599B7E-B879-000C-DCA7-404F6FA7D88B}"/>
+                  </a:ext>
+                </a:extLst>
+              </p:cNvPr>
+              <p:cNvSpPr>
+                <a:spLocks noGrp="1" noRot="1" noChangeAspect="1" noMove="1" noResize="1" noEditPoints="1" noAdjustHandles="1" noChangeArrowheads="1" noChangeShapeType="1" noTextEdit="1"/>
+              </p:cNvSpPr>
+              <p:nvPr>
+                <p:ph idx="1"/>
+              </p:nvPr>
+            </p:nvSpPr>
+            <p:spPr>
+              <a:xfrm>
+                <a:off x="457200" y="1200151"/>
+                <a:ext cx="8229600" cy="3737370"/>
+              </a:xfrm>
+              <a:blipFill>
+                <a:blip r:embed="rId2"/>
+                <a:stretch>
+                  <a:fillRect l="-1111" t="-2284"/>
+                </a:stretch>
+              </a:blipFill>
+            </p:spPr>
+            <p:txBody>
+              <a:bodyPr/>
+              <a:lstStyle/>
+              <a:p>
+                <a:r>
+                  <a:rPr lang="en-US">
+                    <a:noFill/>
+                  </a:rPr>
+                  <a:t> </a:t>
+                </a:r>
+              </a:p>
+            </p:txBody>
+          </p:sp>
+        </mc:Fallback>
+      </mc:AlternateContent>
     </p:spTree>
     <p:extLst>
       <p:ext uri="{BB962C8B-B14F-4D97-AF65-F5344CB8AC3E}">
-        <p14:creationId xmlns:p14="http://schemas.microsoft.com/office/powerpoint/2010/main" val="2617327773"/>
-      </p:ext>
-    </p:extLst>
-  </p:cSld>
-  <p:clrMapOvr>
-    <a:masterClrMapping/>
-  </p:clrMapOvr>
-</p:sld>
-</file>
-
-<file path=ppt/slides/slide59.xml><?xml version="1.0" encoding="utf-8"?>
-<p:sld xmlns:a="http://schemas.openxmlformats.org/drawingml/2006/main" xmlns:r="http://schemas.openxmlformats.org/officeDocument/2006/relationships" xmlns:p="http://schemas.openxmlformats.org/presentationml/2006/main">
-  <p:cSld>
-    <p:spTree>
-      <p:nvGrpSpPr>
-        <p:cNvPr id="1" name="">
-          <a:extLst>
-            <a:ext uri="{FF2B5EF4-FFF2-40B4-BE49-F238E27FC236}">
-              <a16:creationId xmlns:a16="http://schemas.microsoft.com/office/drawing/2014/main" id="{9B5AC65C-F5E9-BA93-5380-0CF56CA21585}"/>
-            </a:ext>
-          </a:extLst>
-        </p:cNvPr>
-        <p:cNvGrpSpPr/>
-        <p:nvPr/>
-      </p:nvGrpSpPr>
-      <p:grpSpPr>
-        <a:xfrm>
-          <a:off x="0" y="0"/>
-          <a:ext cx="0" cy="0"/>
-          <a:chOff x="0" y="0"/>
-          <a:chExt cx="0" cy="0"/>
-        </a:xfrm>
-      </p:grpSpPr>
-      <p:sp>
-        <p:nvSpPr>
-          <p:cNvPr id="2" name="Title 1">
-            <a:extLst>
-              <a:ext uri="{FF2B5EF4-FFF2-40B4-BE49-F238E27FC236}">
-                <a16:creationId xmlns:a16="http://schemas.microsoft.com/office/drawing/2014/main" id="{8963E3C6-E47C-71D3-0D0A-C423D4ADBF8A}"/>
-              </a:ext>
-            </a:extLst>
-          </p:cNvPr>
-          <p:cNvSpPr>
-            <a:spLocks noGrp="1"/>
-          </p:cNvSpPr>
-          <p:nvPr>
-            <p:ph type="title"/>
-          </p:nvPr>
-        </p:nvSpPr>
-        <p:spPr/>
-        <p:txBody>
-          <a:bodyPr/>
-          <a:lstStyle/>
-          <a:p>
-            <a:pPr marL="0" lvl="0" indent="0">
-              <a:buNone/>
-            </a:pPr>
-            <a:r>
-              <a:rPr lang="en-US" dirty="0"/>
-              <a:t>Imputation of Missing Values</a:t>
-            </a:r>
-            <a:endParaRPr dirty="0"/>
-          </a:p>
-        </p:txBody>
-      </p:sp>
-      <p:sp>
-        <p:nvSpPr>
-          <p:cNvPr id="3" name="Content Placeholder 2">
-            <a:extLst>
-              <a:ext uri="{FF2B5EF4-FFF2-40B4-BE49-F238E27FC236}">
-                <a16:creationId xmlns:a16="http://schemas.microsoft.com/office/drawing/2014/main" id="{12343A50-E82E-BC72-EB51-078AFD741C31}"/>
-              </a:ext>
-            </a:extLst>
-          </p:cNvPr>
-          <p:cNvSpPr>
-            <a:spLocks noGrp="1"/>
-          </p:cNvSpPr>
-          <p:nvPr>
-            <p:ph idx="1"/>
-          </p:nvPr>
-        </p:nvSpPr>
-        <p:spPr>
-          <a:xfrm>
-            <a:off x="457200" y="1200151"/>
-            <a:ext cx="8229600" cy="3737370"/>
-          </a:xfrm>
-        </p:spPr>
-        <p:txBody>
-          <a:bodyPr>
-            <a:normAutofit/>
-          </a:bodyPr>
-          <a:lstStyle/>
-          <a:p>
-            <a:pPr marL="0" lvl="0" indent="0">
-              <a:buNone/>
-            </a:pPr>
-            <a:r>
-              <a:rPr lang="en-US" dirty="0"/>
-              <a:t>There are several approaches to imputation for MNAR variables </a:t>
-            </a:r>
-          </a:p>
-          <a:p>
-            <a:r>
-              <a:rPr lang="en-US" dirty="0"/>
-              <a:t>Join with another table – don’t overlook the obvious!</a:t>
-            </a:r>
-          </a:p>
-          <a:p>
-            <a:r>
-              <a:rPr lang="en-US" dirty="0"/>
-              <a:t>Systematic filling    </a:t>
-            </a:r>
-          </a:p>
-          <a:p>
-            <a:pPr lvl="1"/>
-            <a:r>
-              <a:rPr lang="en-US" dirty="0"/>
-              <a:t>Example: are all the missing values 0s     </a:t>
-            </a:r>
-          </a:p>
-          <a:p>
-            <a:pPr lvl="1"/>
-            <a:r>
-              <a:rPr lang="en-US" dirty="0"/>
-              <a:t>Example are the missing values dependent on other specific values of another variable(s)</a:t>
-            </a:r>
-          </a:p>
-          <a:p>
-            <a:r>
-              <a:rPr lang="en-US" dirty="0"/>
-              <a:t>Use autoencoder to learn missing value pattern   </a:t>
-            </a:r>
-          </a:p>
-          <a:p>
-            <a:endParaRPr dirty="0"/>
-          </a:p>
-        </p:txBody>
-      </p:sp>
-    </p:spTree>
-    <p:extLst>
-      <p:ext uri="{BB962C8B-B14F-4D97-AF65-F5344CB8AC3E}">
-        <p14:creationId xmlns:p14="http://schemas.microsoft.com/office/powerpoint/2010/main" val="763742610"/>
+        <p14:creationId xmlns:p14="http://schemas.microsoft.com/office/powerpoint/2010/main" val="3368580357"/>
       </p:ext>
     </p:extLst>
   </p:cSld>
@@ -32388,6 +32799,668 @@
         <p:cNvPr id="1" name="">
           <a:extLst>
             <a:ext uri="{FF2B5EF4-FFF2-40B4-BE49-F238E27FC236}">
+              <a16:creationId xmlns:a16="http://schemas.microsoft.com/office/drawing/2014/main" id="{B2E95FDB-1853-8343-20B0-D9B47438654D}"/>
+            </a:ext>
+          </a:extLst>
+        </p:cNvPr>
+        <p:cNvGrpSpPr/>
+        <p:nvPr/>
+      </p:nvGrpSpPr>
+      <p:grpSpPr>
+        <a:xfrm>
+          <a:off x="0" y="0"/>
+          <a:ext cx="0" cy="0"/>
+          <a:chOff x="0" y="0"/>
+          <a:chExt cx="0" cy="0"/>
+        </a:xfrm>
+      </p:grpSpPr>
+      <p:sp>
+        <p:nvSpPr>
+          <p:cNvPr id="2" name="Title 1">
+            <a:extLst>
+              <a:ext uri="{FF2B5EF4-FFF2-40B4-BE49-F238E27FC236}">
+                <a16:creationId xmlns:a16="http://schemas.microsoft.com/office/drawing/2014/main" id="{62AE1C6E-376E-4A89-0385-7A4648742FBD}"/>
+              </a:ext>
+            </a:extLst>
+          </p:cNvPr>
+          <p:cNvSpPr>
+            <a:spLocks noGrp="1"/>
+          </p:cNvSpPr>
+          <p:nvPr>
+            <p:ph type="title"/>
+          </p:nvPr>
+        </p:nvSpPr>
+        <p:spPr/>
+        <p:txBody>
+          <a:bodyPr/>
+          <a:lstStyle/>
+          <a:p>
+            <a:pPr marL="0" lvl="0" indent="0">
+              <a:buNone/>
+            </a:pPr>
+            <a:r>
+              <a:rPr lang="en-US" dirty="0"/>
+              <a:t>Understanding Missing Values</a:t>
+            </a:r>
+            <a:endParaRPr dirty="0"/>
+          </a:p>
+        </p:txBody>
+      </p:sp>
+      <mc:AlternateContent xmlns:mc="http://schemas.openxmlformats.org/markup-compatibility/2006" xmlns:a14="http://schemas.microsoft.com/office/drawing/2010/main">
+        <mc:Choice Requires="a14">
+          <p:sp>
+            <p:nvSpPr>
+              <p:cNvPr id="3" name="Content Placeholder 2">
+                <a:extLst>
+                  <a:ext uri="{FF2B5EF4-FFF2-40B4-BE49-F238E27FC236}">
+                    <a16:creationId xmlns:a16="http://schemas.microsoft.com/office/drawing/2014/main" id="{CBDBA2D1-06AA-8062-6F0F-7C1864344E52}"/>
+                  </a:ext>
+                </a:extLst>
+              </p:cNvPr>
+              <p:cNvSpPr>
+                <a:spLocks noGrp="1"/>
+              </p:cNvSpPr>
+              <p:nvPr>
+                <p:ph idx="1"/>
+              </p:nvPr>
+            </p:nvSpPr>
+            <p:spPr>
+              <a:xfrm>
+                <a:off x="457200" y="1200151"/>
+                <a:ext cx="8229600" cy="3737370"/>
+              </a:xfrm>
+            </p:spPr>
+            <p:txBody>
+              <a:bodyPr>
+                <a:normAutofit fontScale="92500"/>
+              </a:bodyPr>
+              <a:lstStyle/>
+              <a:p>
+                <a:pPr marL="0" lvl="0" indent="0">
+                  <a:buNone/>
+                </a:pPr>
+                <a:r>
+                  <a:rPr lang="en-US" b="1" dirty="0"/>
+                  <a:t>Little’s MCAR test </a:t>
+                </a:r>
+                <a:r>
+                  <a:rPr lang="en-US" dirty="0"/>
+                  <a:t>has some restrictive assumptions limiting its applicability</a:t>
+                </a:r>
+              </a:p>
+              <a:p>
+                <a:pPr lvl="0"/>
+                <a:r>
+                  <a:rPr lang="en-US" b="1" dirty="0"/>
+                  <a:t>Normality Assumption:</a:t>
+                </a:r>
+                <a:r>
+                  <a:rPr lang="en-US" dirty="0"/>
+                  <a:t> Little’s MCAR test assumes data follow a multivariate normal distribution and works poorly with categorical variables or severe non-normality</a:t>
+                </a:r>
+              </a:p>
+              <a:p>
+                <a:pPr lvl="0"/>
+                <a:r>
+                  <a:rPr lang="en-US" b="1"/>
+                  <a:t>No Specific Variable </a:t>
+                </a:r>
+                <a:r>
+                  <a:rPr lang="en-US" b="1" dirty="0"/>
+                  <a:t>Identification:</a:t>
+                </a:r>
+                <a:r>
+                  <a:rPr lang="en-US" dirty="0"/>
+                  <a:t> Like all such tests you cannot tell which variables result in low p-value </a:t>
+                </a:r>
+              </a:p>
+              <a:p>
+                <a:pPr lvl="1"/>
+                <a:r>
+                  <a:rPr lang="en-US" dirty="0"/>
+                  <a:t>Can apply pairwise</a:t>
+                </a:r>
+              </a:p>
+              <a:p>
+                <a:pPr lvl="0"/>
+                <a:r>
+                  <a:rPr lang="en-US" b="1" dirty="0"/>
+                  <a:t>Failure at High Missing Rates:</a:t>
+                </a:r>
+                <a:r>
+                  <a:rPr lang="en-US" dirty="0"/>
+                  <a:t> Generally, the test is thought to be unreliable (low power) with high rates of missing data, </a:t>
+                </a:r>
+                <a14:m>
+                  <m:oMath xmlns:m="http://schemas.openxmlformats.org/officeDocument/2006/math">
+                    <m:r>
+                      <a:rPr lang="en-US" b="0" i="1" smtClean="0">
+                        <a:latin typeface="Cambria Math" panose="02040503050406030204" pitchFamily="18" charset="0"/>
+                      </a:rPr>
+                      <m:t>&gt;30% </m:t>
+                    </m:r>
+                  </m:oMath>
+                </a14:m>
+                <a:r>
+                  <a:rPr lang="en-US" dirty="0"/>
+                  <a:t> </a:t>
+                </a:r>
+              </a:p>
+              <a:p>
+                <a:endParaRPr dirty="0"/>
+              </a:p>
+            </p:txBody>
+          </p:sp>
+        </mc:Choice>
+        <mc:Fallback xmlns="">
+          <p:sp>
+            <p:nvSpPr>
+              <p:cNvPr id="3" name="Content Placeholder 2">
+                <a:extLst>
+                  <a:ext uri="{FF2B5EF4-FFF2-40B4-BE49-F238E27FC236}">
+                    <a16:creationId xmlns:a16="http://schemas.microsoft.com/office/drawing/2014/main" id="{CBDBA2D1-06AA-8062-6F0F-7C1864344E52}"/>
+                  </a:ext>
+                </a:extLst>
+              </p:cNvPr>
+              <p:cNvSpPr>
+                <a:spLocks noGrp="1" noRot="1" noChangeAspect="1" noMove="1" noResize="1" noEditPoints="1" noAdjustHandles="1" noChangeArrowheads="1" noChangeShapeType="1" noTextEdit="1"/>
+              </p:cNvSpPr>
+              <p:nvPr>
+                <p:ph idx="1"/>
+              </p:nvPr>
+            </p:nvSpPr>
+            <p:spPr>
+              <a:xfrm>
+                <a:off x="457200" y="1200151"/>
+                <a:ext cx="8229600" cy="3737370"/>
+              </a:xfrm>
+              <a:blipFill>
+                <a:blip r:embed="rId2"/>
+                <a:stretch>
+                  <a:fillRect l="-963" t="-1142" b="-1142"/>
+                </a:stretch>
+              </a:blipFill>
+            </p:spPr>
+            <p:txBody>
+              <a:bodyPr/>
+              <a:lstStyle/>
+              <a:p>
+                <a:r>
+                  <a:rPr lang="en-US">
+                    <a:noFill/>
+                  </a:rPr>
+                  <a:t> </a:t>
+                </a:r>
+              </a:p>
+            </p:txBody>
+          </p:sp>
+        </mc:Fallback>
+      </mc:AlternateContent>
+    </p:spTree>
+    <p:extLst>
+      <p:ext uri="{BB962C8B-B14F-4D97-AF65-F5344CB8AC3E}">
+        <p14:creationId xmlns:p14="http://schemas.microsoft.com/office/powerpoint/2010/main" val="2695271168"/>
+      </p:ext>
+    </p:extLst>
+  </p:cSld>
+  <p:clrMapOvr>
+    <a:masterClrMapping/>
+  </p:clrMapOvr>
+</p:sld>
+</file>
+
+<file path=ppt/slides/slide61.xml><?xml version="1.0" encoding="utf-8"?>
+<p:sld xmlns:a="http://schemas.openxmlformats.org/drawingml/2006/main" xmlns:r="http://schemas.openxmlformats.org/officeDocument/2006/relationships" xmlns:p="http://schemas.openxmlformats.org/presentationml/2006/main">
+  <p:cSld>
+    <p:spTree>
+      <p:nvGrpSpPr>
+        <p:cNvPr id="1" name="">
+          <a:extLst>
+            <a:ext uri="{FF2B5EF4-FFF2-40B4-BE49-F238E27FC236}">
+              <a16:creationId xmlns:a16="http://schemas.microsoft.com/office/drawing/2014/main" id="{7169A6A7-2558-E14C-937F-76133ACABB72}"/>
+            </a:ext>
+          </a:extLst>
+        </p:cNvPr>
+        <p:cNvGrpSpPr/>
+        <p:nvPr/>
+      </p:nvGrpSpPr>
+      <p:grpSpPr>
+        <a:xfrm>
+          <a:off x="0" y="0"/>
+          <a:ext cx="0" cy="0"/>
+          <a:chOff x="0" y="0"/>
+          <a:chExt cx="0" cy="0"/>
+        </a:xfrm>
+      </p:grpSpPr>
+      <p:sp>
+        <p:nvSpPr>
+          <p:cNvPr id="2" name="Title 1">
+            <a:extLst>
+              <a:ext uri="{FF2B5EF4-FFF2-40B4-BE49-F238E27FC236}">
+                <a16:creationId xmlns:a16="http://schemas.microsoft.com/office/drawing/2014/main" id="{A919FC23-6B25-1B58-E331-78BC2B52991B}"/>
+              </a:ext>
+            </a:extLst>
+          </p:cNvPr>
+          <p:cNvSpPr>
+            <a:spLocks noGrp="1"/>
+          </p:cNvSpPr>
+          <p:nvPr>
+            <p:ph type="title"/>
+          </p:nvPr>
+        </p:nvSpPr>
+        <p:spPr/>
+        <p:txBody>
+          <a:bodyPr/>
+          <a:lstStyle/>
+          <a:p>
+            <a:pPr marL="0" lvl="0" indent="0">
+              <a:buNone/>
+            </a:pPr>
+            <a:r>
+              <a:rPr lang="en-US" dirty="0"/>
+              <a:t>Imputation of Missing Values</a:t>
+            </a:r>
+            <a:endParaRPr dirty="0"/>
+          </a:p>
+        </p:txBody>
+      </p:sp>
+      <p:sp>
+        <p:nvSpPr>
+          <p:cNvPr id="3" name="Content Placeholder 2">
+            <a:extLst>
+              <a:ext uri="{FF2B5EF4-FFF2-40B4-BE49-F238E27FC236}">
+                <a16:creationId xmlns:a16="http://schemas.microsoft.com/office/drawing/2014/main" id="{C310ECD3-6581-1420-5CE3-136248DB3BEE}"/>
+              </a:ext>
+            </a:extLst>
+          </p:cNvPr>
+          <p:cNvSpPr>
+            <a:spLocks noGrp="1"/>
+          </p:cNvSpPr>
+          <p:nvPr>
+            <p:ph idx="1"/>
+          </p:nvPr>
+        </p:nvSpPr>
+        <p:spPr>
+          <a:xfrm>
+            <a:off x="457200" y="1200151"/>
+            <a:ext cx="8229600" cy="3737370"/>
+          </a:xfrm>
+        </p:spPr>
+        <p:txBody>
+          <a:bodyPr>
+            <a:normAutofit/>
+          </a:bodyPr>
+          <a:lstStyle/>
+          <a:p>
+            <a:pPr marL="0" lvl="0" indent="0">
+              <a:buNone/>
+            </a:pPr>
+            <a:r>
+              <a:rPr lang="en-US" dirty="0"/>
+              <a:t>Imputation methods must match the missing data pattern and intended use</a:t>
+            </a:r>
+          </a:p>
+          <a:p>
+            <a:r>
+              <a:rPr lang="en-US" dirty="0"/>
+              <a:t>Machine learning algorithms only need a good point estimate for the imputed value</a:t>
+            </a:r>
+          </a:p>
+          <a:p>
+            <a:pPr lvl="1"/>
+            <a:r>
+              <a:rPr lang="en-US" dirty="0"/>
+              <a:t>For ML, we do not much care what the confidence intervals are</a:t>
+            </a:r>
+          </a:p>
+          <a:p>
+            <a:r>
+              <a:rPr lang="en-US" dirty="0"/>
+              <a:t>Inference requires drawing imputed values from the distribution of the variable  </a:t>
+            </a:r>
+          </a:p>
+          <a:p>
+            <a:pPr lvl="1"/>
+            <a:r>
+              <a:rPr lang="en-US" dirty="0"/>
+              <a:t>We want unbiased estimates of the confidence intervals  </a:t>
+            </a:r>
+          </a:p>
+          <a:p>
+            <a:endParaRPr dirty="0"/>
+          </a:p>
+        </p:txBody>
+      </p:sp>
+    </p:spTree>
+    <p:extLst>
+      <p:ext uri="{BB962C8B-B14F-4D97-AF65-F5344CB8AC3E}">
+        <p14:creationId xmlns:p14="http://schemas.microsoft.com/office/powerpoint/2010/main" val="1833434833"/>
+      </p:ext>
+    </p:extLst>
+  </p:cSld>
+  <p:clrMapOvr>
+    <a:masterClrMapping/>
+  </p:clrMapOvr>
+</p:sld>
+</file>
+
+<file path=ppt/slides/slide62.xml><?xml version="1.0" encoding="utf-8"?>
+<p:sld xmlns:a="http://schemas.openxmlformats.org/drawingml/2006/main" xmlns:r="http://schemas.openxmlformats.org/officeDocument/2006/relationships" xmlns:p="http://schemas.openxmlformats.org/presentationml/2006/main">
+  <p:cSld>
+    <p:spTree>
+      <p:nvGrpSpPr>
+        <p:cNvPr id="1" name="">
+          <a:extLst>
+            <a:ext uri="{FF2B5EF4-FFF2-40B4-BE49-F238E27FC236}">
+              <a16:creationId xmlns:a16="http://schemas.microsoft.com/office/drawing/2014/main" id="{CE1DAB7D-6678-A6DC-17E0-2F2C67358EC1}"/>
+            </a:ext>
+          </a:extLst>
+        </p:cNvPr>
+        <p:cNvGrpSpPr/>
+        <p:nvPr/>
+      </p:nvGrpSpPr>
+      <p:grpSpPr>
+        <a:xfrm>
+          <a:off x="0" y="0"/>
+          <a:ext cx="0" cy="0"/>
+          <a:chOff x="0" y="0"/>
+          <a:chExt cx="0" cy="0"/>
+        </a:xfrm>
+      </p:grpSpPr>
+      <p:sp>
+        <p:nvSpPr>
+          <p:cNvPr id="2" name="Title 1">
+            <a:extLst>
+              <a:ext uri="{FF2B5EF4-FFF2-40B4-BE49-F238E27FC236}">
+                <a16:creationId xmlns:a16="http://schemas.microsoft.com/office/drawing/2014/main" id="{52A1E7A9-8462-AFB6-69E8-D29C815D4DD0}"/>
+              </a:ext>
+            </a:extLst>
+          </p:cNvPr>
+          <p:cNvSpPr>
+            <a:spLocks noGrp="1"/>
+          </p:cNvSpPr>
+          <p:nvPr>
+            <p:ph type="title"/>
+          </p:nvPr>
+        </p:nvSpPr>
+        <p:spPr/>
+        <p:txBody>
+          <a:bodyPr/>
+          <a:lstStyle/>
+          <a:p>
+            <a:pPr marL="0" lvl="0" indent="0">
+              <a:buNone/>
+            </a:pPr>
+            <a:r>
+              <a:rPr lang="en-US" dirty="0"/>
+              <a:t>Imputation of Missing Values</a:t>
+            </a:r>
+            <a:endParaRPr dirty="0"/>
+          </a:p>
+        </p:txBody>
+      </p:sp>
+      <p:sp>
+        <p:nvSpPr>
+          <p:cNvPr id="3" name="Content Placeholder 2">
+            <a:extLst>
+              <a:ext uri="{FF2B5EF4-FFF2-40B4-BE49-F238E27FC236}">
+                <a16:creationId xmlns:a16="http://schemas.microsoft.com/office/drawing/2014/main" id="{EE8C0F07-8E21-F467-CD9D-1ED0C942B535}"/>
+              </a:ext>
+            </a:extLst>
+          </p:cNvPr>
+          <p:cNvSpPr>
+            <a:spLocks noGrp="1"/>
+          </p:cNvSpPr>
+          <p:nvPr>
+            <p:ph idx="1"/>
+          </p:nvPr>
+        </p:nvSpPr>
+        <p:spPr>
+          <a:xfrm>
+            <a:off x="457200" y="1200151"/>
+            <a:ext cx="8229600" cy="3737370"/>
+          </a:xfrm>
+        </p:spPr>
+        <p:txBody>
+          <a:bodyPr>
+            <a:normAutofit lnSpcReduction="10000"/>
+          </a:bodyPr>
+          <a:lstStyle/>
+          <a:p>
+            <a:pPr marL="0" lvl="0" indent="0">
+              <a:buNone/>
+            </a:pPr>
+            <a:r>
+              <a:rPr lang="en-US" dirty="0"/>
+              <a:t>Algorithms used for MCAR and MAR data for machine learning do not need to preserve distributions</a:t>
+            </a:r>
+          </a:p>
+          <a:p>
+            <a:r>
+              <a:rPr lang="en-US" dirty="0"/>
+              <a:t>Commonly used algorithms for machine </a:t>
+            </a:r>
+            <a:r>
+              <a:rPr lang="en-US" dirty="0" err="1"/>
+              <a:t>learling</a:t>
+            </a:r>
+            <a:r>
+              <a:rPr lang="en-US" dirty="0"/>
+              <a:t> include</a:t>
+            </a:r>
+          </a:p>
+          <a:p>
+            <a:pPr lvl="1"/>
+            <a:r>
+              <a:rPr lang="en-US" dirty="0"/>
+              <a:t>Filling, mean, median, …</a:t>
+            </a:r>
+          </a:p>
+          <a:p>
+            <a:pPr lvl="1"/>
+            <a:r>
+              <a:rPr lang="en-US" dirty="0"/>
+              <a:t>Interpolation, linear, spline, etc.     </a:t>
+            </a:r>
+          </a:p>
+          <a:p>
+            <a:pPr lvl="1"/>
+            <a:r>
+              <a:rPr lang="en-US" dirty="0"/>
+              <a:t>Forward and back filling</a:t>
+            </a:r>
+          </a:p>
+          <a:p>
+            <a:pPr lvl="1"/>
+            <a:r>
+              <a:rPr lang="en-US" dirty="0"/>
+              <a:t>K-nearest neighbors </a:t>
+            </a:r>
+          </a:p>
+          <a:p>
+            <a:pPr lvl="1"/>
+            <a:r>
+              <a:rPr lang="en-US" dirty="0" err="1"/>
+              <a:t>etc</a:t>
+            </a:r>
+            <a:r>
+              <a:rPr lang="en-US" dirty="0"/>
+              <a:t>… </a:t>
+            </a:r>
+          </a:p>
+          <a:p>
+            <a:r>
+              <a:rPr lang="en-US" dirty="0"/>
+              <a:t>These algorithms only provide point estimates and are not useful for inference   </a:t>
+            </a:r>
+          </a:p>
+          <a:p>
+            <a:endParaRPr dirty="0"/>
+          </a:p>
+        </p:txBody>
+      </p:sp>
+    </p:spTree>
+    <p:extLst>
+      <p:ext uri="{BB962C8B-B14F-4D97-AF65-F5344CB8AC3E}">
+        <p14:creationId xmlns:p14="http://schemas.microsoft.com/office/powerpoint/2010/main" val="2617327773"/>
+      </p:ext>
+    </p:extLst>
+  </p:cSld>
+  <p:clrMapOvr>
+    <a:masterClrMapping/>
+  </p:clrMapOvr>
+</p:sld>
+</file>
+
+<file path=ppt/slides/slide63.xml><?xml version="1.0" encoding="utf-8"?>
+<p:sld xmlns:a="http://schemas.openxmlformats.org/drawingml/2006/main" xmlns:r="http://schemas.openxmlformats.org/officeDocument/2006/relationships" xmlns:p="http://schemas.openxmlformats.org/presentationml/2006/main">
+  <p:cSld>
+    <p:spTree>
+      <p:nvGrpSpPr>
+        <p:cNvPr id="1" name="">
+          <a:extLst>
+            <a:ext uri="{FF2B5EF4-FFF2-40B4-BE49-F238E27FC236}">
+              <a16:creationId xmlns:a16="http://schemas.microsoft.com/office/drawing/2014/main" id="{9B5AC65C-F5E9-BA93-5380-0CF56CA21585}"/>
+            </a:ext>
+          </a:extLst>
+        </p:cNvPr>
+        <p:cNvGrpSpPr/>
+        <p:nvPr/>
+      </p:nvGrpSpPr>
+      <p:grpSpPr>
+        <a:xfrm>
+          <a:off x="0" y="0"/>
+          <a:ext cx="0" cy="0"/>
+          <a:chOff x="0" y="0"/>
+          <a:chExt cx="0" cy="0"/>
+        </a:xfrm>
+      </p:grpSpPr>
+      <p:sp>
+        <p:nvSpPr>
+          <p:cNvPr id="2" name="Title 1">
+            <a:extLst>
+              <a:ext uri="{FF2B5EF4-FFF2-40B4-BE49-F238E27FC236}">
+                <a16:creationId xmlns:a16="http://schemas.microsoft.com/office/drawing/2014/main" id="{8963E3C6-E47C-71D3-0D0A-C423D4ADBF8A}"/>
+              </a:ext>
+            </a:extLst>
+          </p:cNvPr>
+          <p:cNvSpPr>
+            <a:spLocks noGrp="1"/>
+          </p:cNvSpPr>
+          <p:nvPr>
+            <p:ph type="title"/>
+          </p:nvPr>
+        </p:nvSpPr>
+        <p:spPr/>
+        <p:txBody>
+          <a:bodyPr/>
+          <a:lstStyle/>
+          <a:p>
+            <a:pPr marL="0" lvl="0" indent="0">
+              <a:buNone/>
+            </a:pPr>
+            <a:r>
+              <a:rPr lang="en-US" dirty="0"/>
+              <a:t>Imputation of Missing Values</a:t>
+            </a:r>
+            <a:endParaRPr dirty="0"/>
+          </a:p>
+        </p:txBody>
+      </p:sp>
+      <p:sp>
+        <p:nvSpPr>
+          <p:cNvPr id="3" name="Content Placeholder 2">
+            <a:extLst>
+              <a:ext uri="{FF2B5EF4-FFF2-40B4-BE49-F238E27FC236}">
+                <a16:creationId xmlns:a16="http://schemas.microsoft.com/office/drawing/2014/main" id="{12343A50-E82E-BC72-EB51-078AFD741C31}"/>
+              </a:ext>
+            </a:extLst>
+          </p:cNvPr>
+          <p:cNvSpPr>
+            <a:spLocks noGrp="1"/>
+          </p:cNvSpPr>
+          <p:nvPr>
+            <p:ph idx="1"/>
+          </p:nvPr>
+        </p:nvSpPr>
+        <p:spPr>
+          <a:xfrm>
+            <a:off x="457200" y="1200151"/>
+            <a:ext cx="8229600" cy="3737370"/>
+          </a:xfrm>
+        </p:spPr>
+        <p:txBody>
+          <a:bodyPr>
+            <a:normAutofit/>
+          </a:bodyPr>
+          <a:lstStyle/>
+          <a:p>
+            <a:pPr marL="0" lvl="0" indent="0">
+              <a:buNone/>
+            </a:pPr>
+            <a:r>
+              <a:rPr lang="en-US" dirty="0"/>
+              <a:t>There are several approaches to imputation for MNAR variables </a:t>
+            </a:r>
+          </a:p>
+          <a:p>
+            <a:r>
+              <a:rPr lang="en-US" dirty="0"/>
+              <a:t>Join with another table – don’t overlook the obvious!</a:t>
+            </a:r>
+          </a:p>
+          <a:p>
+            <a:r>
+              <a:rPr lang="en-US" dirty="0"/>
+              <a:t>Systematic filling    </a:t>
+            </a:r>
+          </a:p>
+          <a:p>
+            <a:pPr lvl="1"/>
+            <a:r>
+              <a:rPr lang="en-US" dirty="0"/>
+              <a:t>Example: are all the missing values 0s     </a:t>
+            </a:r>
+          </a:p>
+          <a:p>
+            <a:pPr lvl="1"/>
+            <a:r>
+              <a:rPr lang="en-US" dirty="0"/>
+              <a:t>Example are the missing values dependent on other specific values of another variable(s)</a:t>
+            </a:r>
+          </a:p>
+          <a:p>
+            <a:r>
+              <a:rPr lang="en-US" dirty="0"/>
+              <a:t>Use autoencoder to learn missing value pattern   </a:t>
+            </a:r>
+          </a:p>
+          <a:p>
+            <a:endParaRPr dirty="0"/>
+          </a:p>
+        </p:txBody>
+      </p:sp>
+    </p:spTree>
+    <p:extLst>
+      <p:ext uri="{BB962C8B-B14F-4D97-AF65-F5344CB8AC3E}">
+        <p14:creationId xmlns:p14="http://schemas.microsoft.com/office/powerpoint/2010/main" val="763742610"/>
+      </p:ext>
+    </p:extLst>
+  </p:cSld>
+  <p:clrMapOvr>
+    <a:masterClrMapping/>
+  </p:clrMapOvr>
+</p:sld>
+</file>
+
+<file path=ppt/slides/slide64.xml><?xml version="1.0" encoding="utf-8"?>
+<p:sld xmlns:a="http://schemas.openxmlformats.org/drawingml/2006/main" xmlns:r="http://schemas.openxmlformats.org/officeDocument/2006/relationships" xmlns:p="http://schemas.openxmlformats.org/presentationml/2006/main">
+  <p:cSld>
+    <p:spTree>
+      <p:nvGrpSpPr>
+        <p:cNvPr id="1" name="">
+          <a:extLst>
+            <a:ext uri="{FF2B5EF4-FFF2-40B4-BE49-F238E27FC236}">
               <a16:creationId xmlns:a16="http://schemas.microsoft.com/office/drawing/2014/main" id="{4ABC3421-F68D-9E08-4B79-AF9B86A06B44}"/>
             </a:ext>
           </a:extLst>
@@ -32647,7 +33720,7 @@
 </p:sld>
 </file>
 
-<file path=ppt/slides/slide61.xml><?xml version="1.0" encoding="utf-8"?>
+<file path=ppt/slides/slide65.xml><?xml version="1.0" encoding="utf-8"?>
 <p:sld xmlns:a="http://schemas.openxmlformats.org/drawingml/2006/main" xmlns:r="http://schemas.openxmlformats.org/officeDocument/2006/relationships" xmlns:p="http://schemas.openxmlformats.org/presentationml/2006/main">
   <p:cSld>
     <p:spTree>
@@ -32797,7 +33870,7 @@
 </p:sld>
 </file>
 
-<file path=ppt/slides/slide62.xml><?xml version="1.0" encoding="utf-8"?>
+<file path=ppt/slides/slide66.xml><?xml version="1.0" encoding="utf-8"?>
 <p:sld xmlns:a="http://schemas.openxmlformats.org/drawingml/2006/main" xmlns:r="http://schemas.openxmlformats.org/officeDocument/2006/relationships" xmlns:p="http://schemas.openxmlformats.org/presentationml/2006/main">
   <p:cSld>
     <p:spTree>
@@ -32926,7 +33999,7 @@
 </p:sld>
 </file>
 
-<file path=ppt/slides/slide63.xml><?xml version="1.0" encoding="utf-8"?>
+<file path=ppt/slides/slide67.xml><?xml version="1.0" encoding="utf-8"?>
 <p:sld xmlns:a="http://schemas.openxmlformats.org/drawingml/2006/main" xmlns:r="http://schemas.openxmlformats.org/officeDocument/2006/relationships" xmlns:p="http://schemas.openxmlformats.org/presentationml/2006/main">
   <p:cSld>
     <p:spTree>
@@ -33074,7 +34147,7 @@
 </p:sld>
 </file>
 
-<file path=ppt/slides/slide64.xml><?xml version="1.0" encoding="utf-8"?>
+<file path=ppt/slides/slide68.xml><?xml version="1.0" encoding="utf-8"?>
 <p:sld xmlns:a="http://schemas.openxmlformats.org/drawingml/2006/main" xmlns:r="http://schemas.openxmlformats.org/officeDocument/2006/relationships" xmlns:p="http://schemas.openxmlformats.org/presentationml/2006/main">
   <p:cSld>
     <p:spTree>
@@ -33217,7 +34290,7 @@
 </p:sld>
 </file>
 
-<file path=ppt/slides/slide65.xml><?xml version="1.0" encoding="utf-8"?>
+<file path=ppt/slides/slide69.xml><?xml version="1.0" encoding="utf-8"?>
 <p:sld xmlns:a="http://schemas.openxmlformats.org/drawingml/2006/main" xmlns:r="http://schemas.openxmlformats.org/officeDocument/2006/relationships" xmlns:p="http://schemas.openxmlformats.org/presentationml/2006/main">
   <p:cSld>
     <p:spTree>
@@ -33272,8 +34345,8 @@
           </a:p>
         </p:txBody>
       </p:sp>
-      <mc:AlternateContent xmlns:mc="http://schemas.openxmlformats.org/markup-compatibility/2006">
-        <mc:Choice xmlns:a14="http://schemas.microsoft.com/office/drawing/2010/main" Requires="a14">
+      <mc:AlternateContent xmlns:mc="http://schemas.openxmlformats.org/markup-compatibility/2006" xmlns:a14="http://schemas.microsoft.com/office/drawing/2010/main">
+        <mc:Choice Requires="a14">
           <p:sp>
             <p:nvSpPr>
               <p:cNvPr id="3" name="Content Placeholder 2">
@@ -33503,7 +34576,7 @@
             </p:txBody>
           </p:sp>
         </mc:Choice>
-        <mc:Fallback>
+        <mc:Fallback xmlns="">
           <p:sp>
             <p:nvSpPr>
               <p:cNvPr id="3" name="Content Placeholder 2">
@@ -33560,7 +34633,386 @@
 </p:sld>
 </file>
 
-<file path=ppt/slides/slide66.xml><?xml version="1.0" encoding="utf-8"?>
+<file path=ppt/slides/slide7.xml><?xml version="1.0" encoding="utf-8"?>
+<p:sld xmlns:a="http://schemas.openxmlformats.org/drawingml/2006/main" xmlns:r="http://schemas.openxmlformats.org/officeDocument/2006/relationships" xmlns:p="http://schemas.openxmlformats.org/presentationml/2006/main">
+  <p:cSld>
+    <p:spTree>
+      <p:nvGrpSpPr>
+        <p:cNvPr id="1" name="">
+          <a:extLst>
+            <a:ext uri="{FF2B5EF4-FFF2-40B4-BE49-F238E27FC236}">
+              <a16:creationId xmlns:a16="http://schemas.microsoft.com/office/drawing/2014/main" id="{B3993F59-9009-4191-4BD0-62EAFBE3087E}"/>
+            </a:ext>
+          </a:extLst>
+        </p:cNvPr>
+        <p:cNvGrpSpPr/>
+        <p:nvPr/>
+      </p:nvGrpSpPr>
+      <p:grpSpPr>
+        <a:xfrm>
+          <a:off x="0" y="0"/>
+          <a:ext cx="0" cy="0"/>
+          <a:chOff x="0" y="0"/>
+          <a:chExt cx="0" cy="0"/>
+        </a:xfrm>
+      </p:grpSpPr>
+      <p:sp>
+        <p:nvSpPr>
+          <p:cNvPr id="2" name="Title 1">
+            <a:extLst>
+              <a:ext uri="{FF2B5EF4-FFF2-40B4-BE49-F238E27FC236}">
+                <a16:creationId xmlns:a16="http://schemas.microsoft.com/office/drawing/2014/main" id="{5A5D5B7B-EC31-F645-671E-3F2116407953}"/>
+              </a:ext>
+            </a:extLst>
+          </p:cNvPr>
+          <p:cNvSpPr>
+            <a:spLocks noGrp="1"/>
+          </p:cNvSpPr>
+          <p:nvPr>
+            <p:ph type="title"/>
+          </p:nvPr>
+        </p:nvSpPr>
+        <p:spPr/>
+        <p:txBody>
+          <a:bodyPr/>
+          <a:lstStyle/>
+          <a:p>
+            <a:pPr marL="0" lvl="0" indent="0">
+              <a:buNone/>
+            </a:pPr>
+            <a:r>
+              <a:rPr lang="en-US" dirty="0"/>
+              <a:t>Modeling Zero-Inflated Distributions</a:t>
+            </a:r>
+            <a:endParaRPr dirty="0"/>
+          </a:p>
+        </p:txBody>
+      </p:sp>
+      <p:sp>
+        <p:nvSpPr>
+          <p:cNvPr id="3" name="Content Placeholder 2">
+            <a:extLst>
+              <a:ext uri="{FF2B5EF4-FFF2-40B4-BE49-F238E27FC236}">
+                <a16:creationId xmlns:a16="http://schemas.microsoft.com/office/drawing/2014/main" id="{4C4AB32E-A8D9-3191-4BF8-4C76B8CCB7FC}"/>
+              </a:ext>
+            </a:extLst>
+          </p:cNvPr>
+          <p:cNvSpPr>
+            <a:spLocks noGrp="1"/>
+          </p:cNvSpPr>
+          <p:nvPr>
+            <p:ph idx="1"/>
+          </p:nvPr>
+        </p:nvSpPr>
+        <p:spPr/>
+        <p:txBody>
+          <a:bodyPr>
+            <a:normAutofit/>
+          </a:bodyPr>
+          <a:lstStyle/>
+          <a:p>
+            <a:pPr marL="0" lvl="0" indent="0">
+              <a:buNone/>
+            </a:pPr>
+            <a:r>
+              <a:rPr lang="en-US" dirty="0"/>
+              <a:t>How can we model zero inflated distributions?  </a:t>
+            </a:r>
+            <a:endParaRPr dirty="0"/>
+          </a:p>
+          <a:p>
+            <a:pPr lvl="0"/>
+            <a:r>
+              <a:rPr lang="en-US" dirty="0"/>
+              <a:t>Standard ‘named’ distributions do not account for zero-inflation  </a:t>
+            </a:r>
+          </a:p>
+          <a:p>
+            <a:pPr lvl="0"/>
+            <a:r>
+              <a:rPr lang="en-US" dirty="0"/>
+              <a:t>Can use a mixture of two distributions  </a:t>
+            </a:r>
+          </a:p>
+          <a:p>
+            <a:pPr lvl="1"/>
+            <a:r>
+              <a:rPr lang="en-US" dirty="0"/>
+              <a:t>A binomial distribution, or switching distribution  </a:t>
+            </a:r>
+          </a:p>
+          <a:p>
+            <a:pPr lvl="1"/>
+            <a:r>
+              <a:rPr lang="en-US" dirty="0"/>
+              <a:t>A standard distribution </a:t>
+            </a:r>
+          </a:p>
+          <a:p>
+            <a:r>
+              <a:rPr lang="en-US" dirty="0"/>
+              <a:t>The binomial distribution serves as a ‘switch’ between 0 response and the other distribution   </a:t>
+            </a:r>
+          </a:p>
+          <a:p>
+            <a:pPr lvl="0"/>
+            <a:endParaRPr dirty="0"/>
+          </a:p>
+        </p:txBody>
+      </p:sp>
+    </p:spTree>
+    <p:extLst>
+      <p:ext uri="{BB962C8B-B14F-4D97-AF65-F5344CB8AC3E}">
+        <p14:creationId xmlns:p14="http://schemas.microsoft.com/office/powerpoint/2010/main" val="4064511800"/>
+      </p:ext>
+    </p:extLst>
+  </p:cSld>
+  <p:clrMapOvr>
+    <a:masterClrMapping/>
+  </p:clrMapOvr>
+  <p:timing>
+    <p:tnLst>
+      <p:par>
+        <p:cTn id="1" dur="indefinite" restart="never" nodeType="tmRoot">
+          <p:childTnLst>
+            <p:seq concurrent="1" nextAc="seek">
+              <p:cTn id="2" dur="indefinite" nodeType="mainSeq">
+                <p:childTnLst>
+                  <p:par>
+                    <p:cTn id="3" fill="hold">
+                      <p:stCondLst>
+                        <p:cond delay="indefinite"/>
+                      </p:stCondLst>
+                      <p:childTnLst>
+                        <p:par>
+                          <p:cTn id="4" fill="hold">
+                            <p:stCondLst>
+                              <p:cond delay="0"/>
+                            </p:stCondLst>
+                            <p:childTnLst>
+                              <p:par>
+                                <p:cTn id="5" presetID="1" presetClass="entr" presetSubtype="0" fill="hold" nodeType="clickEffect">
+                                  <p:stCondLst>
+                                    <p:cond delay="0"/>
+                                  </p:stCondLst>
+                                  <p:childTnLst>
+                                    <p:set>
+                                      <p:cBhvr>
+                                        <p:cTn id="6" dur="1" fill="hold">
+                                          <p:stCondLst>
+                                            <p:cond delay="0"/>
+                                          </p:stCondLst>
+                                        </p:cTn>
+                                        <p:tgtEl>
+                                          <p:spTgt spid="3">
+                                            <p:txEl>
+                                              <p:pRg st="1" end="1"/>
+                                            </p:txEl>
+                                          </p:spTgt>
+                                        </p:tgtEl>
+                                        <p:attrNameLst>
+                                          <p:attrName>style.visibility</p:attrName>
+                                        </p:attrNameLst>
+                                      </p:cBhvr>
+                                      <p:to>
+                                        <p:strVal val="visible"/>
+                                      </p:to>
+                                    </p:set>
+                                  </p:childTnLst>
+                                </p:cTn>
+                              </p:par>
+                            </p:childTnLst>
+                          </p:cTn>
+                        </p:par>
+                      </p:childTnLst>
+                    </p:cTn>
+                  </p:par>
+                  <p:par>
+                    <p:cTn id="7" fill="hold">
+                      <p:stCondLst>
+                        <p:cond delay="indefinite"/>
+                      </p:stCondLst>
+                      <p:childTnLst>
+                        <p:par>
+                          <p:cTn id="8" fill="hold">
+                            <p:stCondLst>
+                              <p:cond delay="0"/>
+                            </p:stCondLst>
+                            <p:childTnLst>
+                              <p:par>
+                                <p:cTn id="9" presetID="1" presetClass="entr" presetSubtype="0" fill="hold" nodeType="clickEffect">
+                                  <p:stCondLst>
+                                    <p:cond delay="0"/>
+                                  </p:stCondLst>
+                                  <p:childTnLst>
+                                    <p:set>
+                                      <p:cBhvr>
+                                        <p:cTn id="10" dur="1" fill="hold">
+                                          <p:stCondLst>
+                                            <p:cond delay="0"/>
+                                          </p:stCondLst>
+                                        </p:cTn>
+                                        <p:tgtEl>
+                                          <p:spTgt spid="3">
+                                            <p:txEl>
+                                              <p:pRg st="2" end="2"/>
+                                            </p:txEl>
+                                          </p:spTgt>
+                                        </p:tgtEl>
+                                        <p:attrNameLst>
+                                          <p:attrName>style.visibility</p:attrName>
+                                        </p:attrNameLst>
+                                      </p:cBhvr>
+                                      <p:to>
+                                        <p:strVal val="visible"/>
+                                      </p:to>
+                                    </p:set>
+                                  </p:childTnLst>
+                                </p:cTn>
+                              </p:par>
+                              <p:par>
+                                <p:cTn id="11" presetID="1" presetClass="entr" presetSubtype="0" fill="hold" nodeType="withEffect">
+                                  <p:stCondLst>
+                                    <p:cond delay="0"/>
+                                  </p:stCondLst>
+                                  <p:childTnLst>
+                                    <p:set>
+                                      <p:cBhvr>
+                                        <p:cTn id="12" dur="1" fill="hold">
+                                          <p:stCondLst>
+                                            <p:cond delay="0"/>
+                                          </p:stCondLst>
+                                        </p:cTn>
+                                        <p:tgtEl>
+                                          <p:spTgt spid="3">
+                                            <p:txEl>
+                                              <p:pRg st="3" end="3"/>
+                                            </p:txEl>
+                                          </p:spTgt>
+                                        </p:tgtEl>
+                                        <p:attrNameLst>
+                                          <p:attrName>style.visibility</p:attrName>
+                                        </p:attrNameLst>
+                                      </p:cBhvr>
+                                      <p:to>
+                                        <p:strVal val="visible"/>
+                                      </p:to>
+                                    </p:set>
+                                  </p:childTnLst>
+                                </p:cTn>
+                              </p:par>
+                              <p:par>
+                                <p:cTn id="13" presetID="1" presetClass="entr" presetSubtype="0" fill="hold" nodeType="withEffect">
+                                  <p:stCondLst>
+                                    <p:cond delay="0"/>
+                                  </p:stCondLst>
+                                  <p:childTnLst>
+                                    <p:set>
+                                      <p:cBhvr>
+                                        <p:cTn id="14" dur="1" fill="hold">
+                                          <p:stCondLst>
+                                            <p:cond delay="0"/>
+                                          </p:stCondLst>
+                                        </p:cTn>
+                                        <p:tgtEl>
+                                          <p:spTgt spid="3">
+                                            <p:txEl>
+                                              <p:pRg st="4" end="4"/>
+                                            </p:txEl>
+                                          </p:spTgt>
+                                        </p:tgtEl>
+                                        <p:attrNameLst>
+                                          <p:attrName>style.visibility</p:attrName>
+                                        </p:attrNameLst>
+                                      </p:cBhvr>
+                                      <p:to>
+                                        <p:strVal val="visible"/>
+                                      </p:to>
+                                    </p:set>
+                                  </p:childTnLst>
+                                </p:cTn>
+                              </p:par>
+                            </p:childTnLst>
+                          </p:cTn>
+                        </p:par>
+                      </p:childTnLst>
+                    </p:cTn>
+                  </p:par>
+                  <p:par>
+                    <p:cTn id="15" fill="hold">
+                      <p:stCondLst>
+                        <p:cond delay="indefinite"/>
+                      </p:stCondLst>
+                      <p:childTnLst>
+                        <p:par>
+                          <p:cTn id="16" fill="hold">
+                            <p:stCondLst>
+                              <p:cond delay="0"/>
+                            </p:stCondLst>
+                            <p:childTnLst>
+                              <p:par>
+                                <p:cTn id="17" presetID="1" presetClass="entr" presetSubtype="0" fill="hold" nodeType="clickEffect">
+                                  <p:stCondLst>
+                                    <p:cond delay="0"/>
+                                  </p:stCondLst>
+                                  <p:childTnLst>
+                                    <p:set>
+                                      <p:cBhvr>
+                                        <p:cTn id="18" dur="1" fill="hold">
+                                          <p:stCondLst>
+                                            <p:cond delay="0"/>
+                                          </p:stCondLst>
+                                        </p:cTn>
+                                        <p:tgtEl>
+                                          <p:spTgt spid="3">
+                                            <p:txEl>
+                                              <p:pRg st="5" end="5"/>
+                                            </p:txEl>
+                                          </p:spTgt>
+                                        </p:tgtEl>
+                                        <p:attrNameLst>
+                                          <p:attrName>style.visibility</p:attrName>
+                                        </p:attrNameLst>
+                                      </p:cBhvr>
+                                      <p:to>
+                                        <p:strVal val="visible"/>
+                                      </p:to>
+                                    </p:set>
+                                  </p:childTnLst>
+                                </p:cTn>
+                              </p:par>
+                            </p:childTnLst>
+                          </p:cTn>
+                        </p:par>
+                      </p:childTnLst>
+                    </p:cTn>
+                  </p:par>
+                </p:childTnLst>
+              </p:cTn>
+              <p:prevCondLst>
+                <p:cond evt="onPrev" delay="0">
+                  <p:tgtEl>
+                    <p:sldTgt/>
+                  </p:tgtEl>
+                </p:cond>
+              </p:prevCondLst>
+              <p:nextCondLst>
+                <p:cond evt="onNext" delay="0">
+                  <p:tgtEl>
+                    <p:sldTgt/>
+                  </p:tgtEl>
+                </p:cond>
+              </p:nextCondLst>
+            </p:seq>
+          </p:childTnLst>
+        </p:cTn>
+      </p:par>
+    </p:tnLst>
+  </p:timing>
+</p:sld>
+</file>
+
+<file path=ppt/slides/slide70.xml><?xml version="1.0" encoding="utf-8"?>
 <p:sld xmlns:a="http://schemas.openxmlformats.org/drawingml/2006/main" xmlns:r="http://schemas.openxmlformats.org/officeDocument/2006/relationships" xmlns:p="http://schemas.openxmlformats.org/presentationml/2006/main">
   <p:cSld>
     <p:spTree>
@@ -33615,8 +35067,8 @@
           </a:p>
         </p:txBody>
       </p:sp>
-      <mc:AlternateContent xmlns:mc="http://schemas.openxmlformats.org/markup-compatibility/2006">
-        <mc:Choice xmlns:a14="http://schemas.microsoft.com/office/drawing/2010/main" Requires="a14">
+      <mc:AlternateContent xmlns:mc="http://schemas.openxmlformats.org/markup-compatibility/2006" xmlns:a14="http://schemas.microsoft.com/office/drawing/2010/main">
+        <mc:Choice Requires="a14">
           <p:sp>
             <p:nvSpPr>
               <p:cNvPr id="3" name="Content Placeholder 2">
@@ -34089,7 +35541,7 @@
                         <m:sSup>
                           <m:sSupPr>
                             <m:ctrlPr>
-                              <a:rPr lang="en-US" i="1" smtClean="0">
+                              <a:rPr lang="en-US" b="0" i="1" smtClean="0">
                                 <a:latin typeface="Cambria Math" panose="02040503050406030204" pitchFamily="18" charset="0"/>
                               </a:rPr>
                             </m:ctrlPr>
@@ -34162,7 +35614,7 @@
             </p:txBody>
           </p:sp>
         </mc:Choice>
-        <mc:Fallback>
+        <mc:Fallback xmlns="">
           <p:sp>
             <p:nvSpPr>
               <p:cNvPr id="3" name="Content Placeholder 2">
@@ -34219,7 +35671,776 @@
 </p:sld>
 </file>
 
-<file path=ppt/slides/slide67.xml><?xml version="1.0" encoding="utf-8"?>
+<file path=ppt/slides/slide71.xml><?xml version="1.0" encoding="utf-8"?>
+<p:sld xmlns:a="http://schemas.openxmlformats.org/drawingml/2006/main" xmlns:r="http://schemas.openxmlformats.org/officeDocument/2006/relationships" xmlns:p="http://schemas.openxmlformats.org/presentationml/2006/main">
+  <p:cSld>
+    <p:spTree>
+      <p:nvGrpSpPr>
+        <p:cNvPr id="1" name="">
+          <a:extLst>
+            <a:ext uri="{FF2B5EF4-FFF2-40B4-BE49-F238E27FC236}">
+              <a16:creationId xmlns:a16="http://schemas.microsoft.com/office/drawing/2014/main" id="{28DDD204-02A5-4C7D-94AC-03D691A946EF}"/>
+            </a:ext>
+          </a:extLst>
+        </p:cNvPr>
+        <p:cNvGrpSpPr/>
+        <p:nvPr/>
+      </p:nvGrpSpPr>
+      <p:grpSpPr>
+        <a:xfrm>
+          <a:off x="0" y="0"/>
+          <a:ext cx="0" cy="0"/>
+          <a:chOff x="0" y="0"/>
+          <a:chExt cx="0" cy="0"/>
+        </a:xfrm>
+      </p:grpSpPr>
+      <p:sp>
+        <p:nvSpPr>
+          <p:cNvPr id="2" name="Title 1">
+            <a:extLst>
+              <a:ext uri="{FF2B5EF4-FFF2-40B4-BE49-F238E27FC236}">
+                <a16:creationId xmlns:a16="http://schemas.microsoft.com/office/drawing/2014/main" id="{A2F0256E-0122-8881-335F-1BFB8BE1BFD1}"/>
+              </a:ext>
+            </a:extLst>
+          </p:cNvPr>
+          <p:cNvSpPr>
+            <a:spLocks noGrp="1"/>
+          </p:cNvSpPr>
+          <p:nvPr>
+            <p:ph type="title"/>
+          </p:nvPr>
+        </p:nvSpPr>
+        <p:spPr/>
+        <p:txBody>
+          <a:bodyPr/>
+          <a:lstStyle/>
+          <a:p>
+            <a:pPr marL="0" lvl="0" indent="0">
+              <a:buNone/>
+            </a:pPr>
+            <a:r>
+              <a:rPr lang="en-US" dirty="0"/>
+              <a:t>Imputing Missing Values</a:t>
+            </a:r>
+            <a:endParaRPr dirty="0"/>
+          </a:p>
+        </p:txBody>
+      </p:sp>
+      <p:sp>
+        <p:nvSpPr>
+          <p:cNvPr id="3" name="Content Placeholder 2">
+            <a:extLst>
+              <a:ext uri="{FF2B5EF4-FFF2-40B4-BE49-F238E27FC236}">
+                <a16:creationId xmlns:a16="http://schemas.microsoft.com/office/drawing/2014/main" id="{B3518033-C630-C463-BBC8-5492514F1494}"/>
+              </a:ext>
+            </a:extLst>
+          </p:cNvPr>
+          <p:cNvSpPr>
+            <a:spLocks noGrp="1"/>
+          </p:cNvSpPr>
+          <p:nvPr>
+            <p:ph idx="1"/>
+          </p:nvPr>
+        </p:nvSpPr>
+        <p:spPr>
+          <a:xfrm>
+            <a:off x="457200" y="1146006"/>
+            <a:ext cx="8229600" cy="520365"/>
+          </a:xfrm>
+        </p:spPr>
+        <p:txBody>
+          <a:bodyPr>
+            <a:normAutofit/>
+          </a:bodyPr>
+          <a:lstStyle/>
+          <a:p>
+            <a:pPr marL="0" lvl="0" indent="0">
+              <a:buNone/>
+            </a:pPr>
+            <a:r>
+              <a:rPr lang="en-US" dirty="0"/>
+              <a:t>We can visualize the quality of the imputed results </a:t>
+            </a:r>
+          </a:p>
+          <a:p>
+            <a:endParaRPr dirty="0"/>
+          </a:p>
+        </p:txBody>
+      </p:sp>
+      <p:sp>
+        <p:nvSpPr>
+          <p:cNvPr id="4" name="Content Placeholder 2">
+            <a:extLst>
+              <a:ext uri="{FF2B5EF4-FFF2-40B4-BE49-F238E27FC236}">
+                <a16:creationId xmlns:a16="http://schemas.microsoft.com/office/drawing/2014/main" id="{EC6A6F6A-4C4C-D14B-7204-E38796CFBE53}"/>
+              </a:ext>
+            </a:extLst>
+          </p:cNvPr>
+          <p:cNvSpPr txBox="1">
+            <a:spLocks/>
+          </p:cNvSpPr>
+          <p:nvPr/>
+        </p:nvSpPr>
+        <p:spPr>
+          <a:xfrm>
+            <a:off x="457200" y="1872916"/>
+            <a:ext cx="4002505" cy="2891589"/>
+          </a:xfrm>
+          <a:prstGeom prst="rect">
+            <a:avLst/>
+          </a:prstGeom>
+        </p:spPr>
+        <p:txBody>
+          <a:bodyPr vert="horz" lIns="91440" tIns="45720" rIns="91440" bIns="45720" rtlCol="0">
+            <a:normAutofit/>
+          </a:bodyPr>
+          <a:lstStyle>
+            <a:lvl1pPr marL="342900" indent="-342900" algn="l" defTabSz="342900" rtl="0" eaLnBrk="1" latinLnBrk="0" hangingPunct="1">
+              <a:spcBef>
+                <a:spcPct val="20000"/>
+              </a:spcBef>
+              <a:buFont typeface="Arial"/>
+              <a:buChar char="•"/>
+              <a:defRPr sz="2400" kern="1200">
+                <a:solidFill>
+                  <a:schemeClr val="tx1"/>
+                </a:solidFill>
+                <a:latin typeface="+mn-lt"/>
+                <a:ea typeface="+mn-ea"/>
+                <a:cs typeface="+mn-cs"/>
+              </a:defRPr>
+            </a:lvl1pPr>
+            <a:lvl2pPr marL="685800" indent="-342900" algn="l" defTabSz="342900" rtl="0" eaLnBrk="1" latinLnBrk="0" hangingPunct="1">
+              <a:spcBef>
+                <a:spcPct val="20000"/>
+              </a:spcBef>
+              <a:buFont typeface="Arial"/>
+              <a:buChar char="–"/>
+              <a:defRPr sz="2100" kern="1200">
+                <a:solidFill>
+                  <a:schemeClr val="tx1"/>
+                </a:solidFill>
+                <a:latin typeface="+mn-lt"/>
+                <a:ea typeface="+mn-ea"/>
+                <a:cs typeface="+mn-cs"/>
+              </a:defRPr>
+            </a:lvl2pPr>
+            <a:lvl3pPr marL="1028700" indent="-342900" algn="l" defTabSz="342900" rtl="0" eaLnBrk="1" latinLnBrk="0" hangingPunct="1">
+              <a:spcBef>
+                <a:spcPct val="20000"/>
+              </a:spcBef>
+              <a:buFont typeface="Arial"/>
+              <a:buChar char="•"/>
+              <a:defRPr sz="1800" kern="1200">
+                <a:solidFill>
+                  <a:schemeClr val="tx1"/>
+                </a:solidFill>
+                <a:latin typeface="+mn-lt"/>
+                <a:ea typeface="+mn-ea"/>
+                <a:cs typeface="+mn-cs"/>
+              </a:defRPr>
+            </a:lvl3pPr>
+            <a:lvl4pPr marL="1371600" indent="-342900" algn="l" defTabSz="342900" rtl="0" eaLnBrk="1" latinLnBrk="0" hangingPunct="1">
+              <a:spcBef>
+                <a:spcPct val="20000"/>
+              </a:spcBef>
+              <a:buFont typeface="Arial"/>
+              <a:buChar char="–"/>
+              <a:defRPr sz="1500" kern="1200">
+                <a:solidFill>
+                  <a:schemeClr val="tx1"/>
+                </a:solidFill>
+                <a:latin typeface="+mn-lt"/>
+                <a:ea typeface="+mn-ea"/>
+                <a:cs typeface="+mn-cs"/>
+              </a:defRPr>
+            </a:lvl4pPr>
+            <a:lvl5pPr marL="1714500" indent="-342900" algn="l" defTabSz="342900" rtl="0" eaLnBrk="1" latinLnBrk="0" hangingPunct="1">
+              <a:spcBef>
+                <a:spcPct val="20000"/>
+              </a:spcBef>
+              <a:buFont typeface="Arial"/>
+              <a:buChar char="»"/>
+              <a:defRPr sz="1500" kern="1200">
+                <a:solidFill>
+                  <a:schemeClr val="tx1"/>
+                </a:solidFill>
+                <a:latin typeface="+mn-lt"/>
+                <a:ea typeface="+mn-ea"/>
+                <a:cs typeface="+mn-cs"/>
+              </a:defRPr>
+            </a:lvl5pPr>
+            <a:lvl6pPr marL="2057400" indent="-342900" algn="l" defTabSz="342900" rtl="0" eaLnBrk="1" latinLnBrk="0" hangingPunct="1">
+              <a:spcBef>
+                <a:spcPct val="20000"/>
+              </a:spcBef>
+              <a:buFont typeface="Arial"/>
+              <a:buChar char="•"/>
+              <a:defRPr sz="1500" kern="1200">
+                <a:solidFill>
+                  <a:schemeClr val="tx1"/>
+                </a:solidFill>
+                <a:latin typeface="+mn-lt"/>
+                <a:ea typeface="+mn-ea"/>
+                <a:cs typeface="+mn-cs"/>
+              </a:defRPr>
+            </a:lvl6pPr>
+            <a:lvl7pPr marL="2400300" indent="-342900" algn="l" defTabSz="342900" rtl="0" eaLnBrk="1" latinLnBrk="0" hangingPunct="1">
+              <a:spcBef>
+                <a:spcPct val="20000"/>
+              </a:spcBef>
+              <a:buFont typeface="Arial"/>
+              <a:buChar char="•"/>
+              <a:defRPr sz="1500" kern="1200">
+                <a:solidFill>
+                  <a:schemeClr val="tx1"/>
+                </a:solidFill>
+                <a:latin typeface="+mn-lt"/>
+                <a:ea typeface="+mn-ea"/>
+                <a:cs typeface="+mn-cs"/>
+              </a:defRPr>
+            </a:lvl7pPr>
+            <a:lvl8pPr marL="2743200" indent="-342900" algn="l" defTabSz="342900" rtl="0" eaLnBrk="1" latinLnBrk="0" hangingPunct="1">
+              <a:spcBef>
+                <a:spcPct val="20000"/>
+              </a:spcBef>
+              <a:buFont typeface="Arial"/>
+              <a:buChar char="•"/>
+              <a:defRPr sz="1500" kern="1200">
+                <a:solidFill>
+                  <a:schemeClr val="tx1"/>
+                </a:solidFill>
+                <a:latin typeface="+mn-lt"/>
+                <a:ea typeface="+mn-ea"/>
+                <a:cs typeface="+mn-cs"/>
+              </a:defRPr>
+            </a:lvl8pPr>
+            <a:lvl9pPr marL="3086100" indent="-342900" algn="l" defTabSz="342900" rtl="0" eaLnBrk="1" latinLnBrk="0" hangingPunct="1">
+              <a:spcBef>
+                <a:spcPct val="20000"/>
+              </a:spcBef>
+              <a:buFont typeface="Arial"/>
+              <a:buChar char="•"/>
+              <a:defRPr sz="1500" kern="1200">
+                <a:solidFill>
+                  <a:schemeClr val="tx1"/>
+                </a:solidFill>
+                <a:latin typeface="+mn-lt"/>
+                <a:ea typeface="+mn-ea"/>
+                <a:cs typeface="+mn-cs"/>
+              </a:defRPr>
+            </a:lvl9pPr>
+          </a:lstStyle>
+          <a:p>
+            <a:r>
+              <a:rPr lang="en-US" dirty="0"/>
+              <a:t>The distributions of imputed and observed values should match</a:t>
+            </a:r>
+          </a:p>
+          <a:p>
+            <a:endParaRPr lang="en-US" dirty="0"/>
+          </a:p>
+          <a:p>
+            <a:endParaRPr lang="en-US" dirty="0"/>
+          </a:p>
+        </p:txBody>
+      </p:sp>
+      <p:pic>
+        <p:nvPicPr>
+          <p:cNvPr id="6" name="Picture 5">
+            <a:extLst>
+              <a:ext uri="{FF2B5EF4-FFF2-40B4-BE49-F238E27FC236}">
+                <a16:creationId xmlns:a16="http://schemas.microsoft.com/office/drawing/2014/main" id="{D587DBF9-0D43-0A27-06D4-7C7F5BBAB6D1}"/>
+              </a:ext>
+            </a:extLst>
+          </p:cNvPr>
+          <p:cNvPicPr>
+            <a:picLocks noChangeAspect="1"/>
+          </p:cNvPicPr>
+          <p:nvPr/>
+        </p:nvPicPr>
+        <p:blipFill>
+          <a:blip r:embed="rId2"/>
+          <a:stretch>
+            <a:fillRect/>
+          </a:stretch>
+        </p:blipFill>
+        <p:spPr>
+          <a:xfrm>
+            <a:off x="4503821" y="1749148"/>
+            <a:ext cx="4483337" cy="3348036"/>
+          </a:xfrm>
+          <a:prstGeom prst="rect">
+            <a:avLst/>
+          </a:prstGeom>
+        </p:spPr>
+      </p:pic>
+    </p:spTree>
+    <p:extLst>
+      <p:ext uri="{BB962C8B-B14F-4D97-AF65-F5344CB8AC3E}">
+        <p14:creationId xmlns:p14="http://schemas.microsoft.com/office/powerpoint/2010/main" val="1690185777"/>
+      </p:ext>
+    </p:extLst>
+  </p:cSld>
+  <p:clrMapOvr>
+    <a:masterClrMapping/>
+  </p:clrMapOvr>
+</p:sld>
+</file>
+
+<file path=ppt/slides/slide72.xml><?xml version="1.0" encoding="utf-8"?>
+<p:sld xmlns:a="http://schemas.openxmlformats.org/drawingml/2006/main" xmlns:r="http://schemas.openxmlformats.org/officeDocument/2006/relationships" xmlns:p="http://schemas.openxmlformats.org/presentationml/2006/main">
+  <p:cSld>
+    <p:spTree>
+      <p:nvGrpSpPr>
+        <p:cNvPr id="1" name="">
+          <a:extLst>
+            <a:ext uri="{FF2B5EF4-FFF2-40B4-BE49-F238E27FC236}">
+              <a16:creationId xmlns:a16="http://schemas.microsoft.com/office/drawing/2014/main" id="{A770891B-F205-F94D-41EB-427DEE81C67A}"/>
+            </a:ext>
+          </a:extLst>
+        </p:cNvPr>
+        <p:cNvGrpSpPr/>
+        <p:nvPr/>
+      </p:nvGrpSpPr>
+      <p:grpSpPr>
+        <a:xfrm>
+          <a:off x="0" y="0"/>
+          <a:ext cx="0" cy="0"/>
+          <a:chOff x="0" y="0"/>
+          <a:chExt cx="0" cy="0"/>
+        </a:xfrm>
+      </p:grpSpPr>
+      <p:sp>
+        <p:nvSpPr>
+          <p:cNvPr id="2" name="Title 1">
+            <a:extLst>
+              <a:ext uri="{FF2B5EF4-FFF2-40B4-BE49-F238E27FC236}">
+                <a16:creationId xmlns:a16="http://schemas.microsoft.com/office/drawing/2014/main" id="{168B350F-CE79-8679-F991-FC7A70E444C3}"/>
+              </a:ext>
+            </a:extLst>
+          </p:cNvPr>
+          <p:cNvSpPr>
+            <a:spLocks noGrp="1"/>
+          </p:cNvSpPr>
+          <p:nvPr>
+            <p:ph type="title"/>
+          </p:nvPr>
+        </p:nvSpPr>
+        <p:spPr/>
+        <p:txBody>
+          <a:bodyPr/>
+          <a:lstStyle/>
+          <a:p>
+            <a:pPr marL="0" lvl="0" indent="0">
+              <a:buNone/>
+            </a:pPr>
+            <a:r>
+              <a:rPr lang="en-US" dirty="0"/>
+              <a:t>Imputing Missing Values</a:t>
+            </a:r>
+            <a:endParaRPr dirty="0"/>
+          </a:p>
+        </p:txBody>
+      </p:sp>
+      <p:sp>
+        <p:nvSpPr>
+          <p:cNvPr id="3" name="Content Placeholder 2">
+            <a:extLst>
+              <a:ext uri="{FF2B5EF4-FFF2-40B4-BE49-F238E27FC236}">
+                <a16:creationId xmlns:a16="http://schemas.microsoft.com/office/drawing/2014/main" id="{29F3A58E-C420-D9E3-3C9F-030B2AD0212D}"/>
+              </a:ext>
+            </a:extLst>
+          </p:cNvPr>
+          <p:cNvSpPr>
+            <a:spLocks noGrp="1"/>
+          </p:cNvSpPr>
+          <p:nvPr>
+            <p:ph idx="1"/>
+          </p:nvPr>
+        </p:nvSpPr>
+        <p:spPr>
+          <a:xfrm>
+            <a:off x="457200" y="1146006"/>
+            <a:ext cx="8229600" cy="520365"/>
+          </a:xfrm>
+        </p:spPr>
+        <p:txBody>
+          <a:bodyPr>
+            <a:normAutofit/>
+          </a:bodyPr>
+          <a:lstStyle/>
+          <a:p>
+            <a:pPr marL="0" lvl="0" indent="0">
+              <a:buNone/>
+            </a:pPr>
+            <a:r>
+              <a:rPr lang="en-US" dirty="0"/>
+              <a:t>We can visualize the quality of the imputed results </a:t>
+            </a:r>
+          </a:p>
+          <a:p>
+            <a:endParaRPr dirty="0"/>
+          </a:p>
+        </p:txBody>
+      </p:sp>
+      <p:sp>
+        <p:nvSpPr>
+          <p:cNvPr id="4" name="Content Placeholder 2">
+            <a:extLst>
+              <a:ext uri="{FF2B5EF4-FFF2-40B4-BE49-F238E27FC236}">
+                <a16:creationId xmlns:a16="http://schemas.microsoft.com/office/drawing/2014/main" id="{F4F51AFB-2D5F-8DEA-6A00-F7CB6777C5B8}"/>
+              </a:ext>
+            </a:extLst>
+          </p:cNvPr>
+          <p:cNvSpPr txBox="1">
+            <a:spLocks/>
+          </p:cNvSpPr>
+          <p:nvPr/>
+        </p:nvSpPr>
+        <p:spPr>
+          <a:xfrm>
+            <a:off x="457200" y="1872916"/>
+            <a:ext cx="4002505" cy="2891589"/>
+          </a:xfrm>
+          <a:prstGeom prst="rect">
+            <a:avLst/>
+          </a:prstGeom>
+        </p:spPr>
+        <p:txBody>
+          <a:bodyPr vert="horz" lIns="91440" tIns="45720" rIns="91440" bIns="45720" rtlCol="0">
+            <a:normAutofit/>
+          </a:bodyPr>
+          <a:lstStyle>
+            <a:lvl1pPr marL="342900" indent="-342900" algn="l" defTabSz="342900" rtl="0" eaLnBrk="1" latinLnBrk="0" hangingPunct="1">
+              <a:spcBef>
+                <a:spcPct val="20000"/>
+              </a:spcBef>
+              <a:buFont typeface="Arial"/>
+              <a:buChar char="•"/>
+              <a:defRPr sz="2400" kern="1200">
+                <a:solidFill>
+                  <a:schemeClr val="tx1"/>
+                </a:solidFill>
+                <a:latin typeface="+mn-lt"/>
+                <a:ea typeface="+mn-ea"/>
+                <a:cs typeface="+mn-cs"/>
+              </a:defRPr>
+            </a:lvl1pPr>
+            <a:lvl2pPr marL="685800" indent="-342900" algn="l" defTabSz="342900" rtl="0" eaLnBrk="1" latinLnBrk="0" hangingPunct="1">
+              <a:spcBef>
+                <a:spcPct val="20000"/>
+              </a:spcBef>
+              <a:buFont typeface="Arial"/>
+              <a:buChar char="–"/>
+              <a:defRPr sz="2100" kern="1200">
+                <a:solidFill>
+                  <a:schemeClr val="tx1"/>
+                </a:solidFill>
+                <a:latin typeface="+mn-lt"/>
+                <a:ea typeface="+mn-ea"/>
+                <a:cs typeface="+mn-cs"/>
+              </a:defRPr>
+            </a:lvl2pPr>
+            <a:lvl3pPr marL="1028700" indent="-342900" algn="l" defTabSz="342900" rtl="0" eaLnBrk="1" latinLnBrk="0" hangingPunct="1">
+              <a:spcBef>
+                <a:spcPct val="20000"/>
+              </a:spcBef>
+              <a:buFont typeface="Arial"/>
+              <a:buChar char="•"/>
+              <a:defRPr sz="1800" kern="1200">
+                <a:solidFill>
+                  <a:schemeClr val="tx1"/>
+                </a:solidFill>
+                <a:latin typeface="+mn-lt"/>
+                <a:ea typeface="+mn-ea"/>
+                <a:cs typeface="+mn-cs"/>
+              </a:defRPr>
+            </a:lvl3pPr>
+            <a:lvl4pPr marL="1371600" indent="-342900" algn="l" defTabSz="342900" rtl="0" eaLnBrk="1" latinLnBrk="0" hangingPunct="1">
+              <a:spcBef>
+                <a:spcPct val="20000"/>
+              </a:spcBef>
+              <a:buFont typeface="Arial"/>
+              <a:buChar char="–"/>
+              <a:defRPr sz="1500" kern="1200">
+                <a:solidFill>
+                  <a:schemeClr val="tx1"/>
+                </a:solidFill>
+                <a:latin typeface="+mn-lt"/>
+                <a:ea typeface="+mn-ea"/>
+                <a:cs typeface="+mn-cs"/>
+              </a:defRPr>
+            </a:lvl4pPr>
+            <a:lvl5pPr marL="1714500" indent="-342900" algn="l" defTabSz="342900" rtl="0" eaLnBrk="1" latinLnBrk="0" hangingPunct="1">
+              <a:spcBef>
+                <a:spcPct val="20000"/>
+              </a:spcBef>
+              <a:buFont typeface="Arial"/>
+              <a:buChar char="»"/>
+              <a:defRPr sz="1500" kern="1200">
+                <a:solidFill>
+                  <a:schemeClr val="tx1"/>
+                </a:solidFill>
+                <a:latin typeface="+mn-lt"/>
+                <a:ea typeface="+mn-ea"/>
+                <a:cs typeface="+mn-cs"/>
+              </a:defRPr>
+            </a:lvl5pPr>
+            <a:lvl6pPr marL="2057400" indent="-342900" algn="l" defTabSz="342900" rtl="0" eaLnBrk="1" latinLnBrk="0" hangingPunct="1">
+              <a:spcBef>
+                <a:spcPct val="20000"/>
+              </a:spcBef>
+              <a:buFont typeface="Arial"/>
+              <a:buChar char="•"/>
+              <a:defRPr sz="1500" kern="1200">
+                <a:solidFill>
+                  <a:schemeClr val="tx1"/>
+                </a:solidFill>
+                <a:latin typeface="+mn-lt"/>
+                <a:ea typeface="+mn-ea"/>
+                <a:cs typeface="+mn-cs"/>
+              </a:defRPr>
+            </a:lvl6pPr>
+            <a:lvl7pPr marL="2400300" indent="-342900" algn="l" defTabSz="342900" rtl="0" eaLnBrk="1" latinLnBrk="0" hangingPunct="1">
+              <a:spcBef>
+                <a:spcPct val="20000"/>
+              </a:spcBef>
+              <a:buFont typeface="Arial"/>
+              <a:buChar char="•"/>
+              <a:defRPr sz="1500" kern="1200">
+                <a:solidFill>
+                  <a:schemeClr val="tx1"/>
+                </a:solidFill>
+                <a:latin typeface="+mn-lt"/>
+                <a:ea typeface="+mn-ea"/>
+                <a:cs typeface="+mn-cs"/>
+              </a:defRPr>
+            </a:lvl7pPr>
+            <a:lvl8pPr marL="2743200" indent="-342900" algn="l" defTabSz="342900" rtl="0" eaLnBrk="1" latinLnBrk="0" hangingPunct="1">
+              <a:spcBef>
+                <a:spcPct val="20000"/>
+              </a:spcBef>
+              <a:buFont typeface="Arial"/>
+              <a:buChar char="•"/>
+              <a:defRPr sz="1500" kern="1200">
+                <a:solidFill>
+                  <a:schemeClr val="tx1"/>
+                </a:solidFill>
+                <a:latin typeface="+mn-lt"/>
+                <a:ea typeface="+mn-ea"/>
+                <a:cs typeface="+mn-cs"/>
+              </a:defRPr>
+            </a:lvl8pPr>
+            <a:lvl9pPr marL="3086100" indent="-342900" algn="l" defTabSz="342900" rtl="0" eaLnBrk="1" latinLnBrk="0" hangingPunct="1">
+              <a:spcBef>
+                <a:spcPct val="20000"/>
+              </a:spcBef>
+              <a:buFont typeface="Arial"/>
+              <a:buChar char="•"/>
+              <a:defRPr sz="1500" kern="1200">
+                <a:solidFill>
+                  <a:schemeClr val="tx1"/>
+                </a:solidFill>
+                <a:latin typeface="+mn-lt"/>
+                <a:ea typeface="+mn-ea"/>
+                <a:cs typeface="+mn-cs"/>
+              </a:defRPr>
+            </a:lvl9pPr>
+          </a:lstStyle>
+          <a:p>
+            <a:r>
+              <a:rPr lang="en-US" dirty="0"/>
+              <a:t>Biplots show the relationship of observed and imputed values between two variables </a:t>
+            </a:r>
+          </a:p>
+          <a:p>
+            <a:endParaRPr lang="en-US" dirty="0"/>
+          </a:p>
+          <a:p>
+            <a:endParaRPr lang="en-US" dirty="0"/>
+          </a:p>
+        </p:txBody>
+      </p:sp>
+      <p:pic>
+        <p:nvPicPr>
+          <p:cNvPr id="7" name="Picture 6">
+            <a:extLst>
+              <a:ext uri="{FF2B5EF4-FFF2-40B4-BE49-F238E27FC236}">
+                <a16:creationId xmlns:a16="http://schemas.microsoft.com/office/drawing/2014/main" id="{65808BB2-1393-4E26-5116-8482A55BA6D4}"/>
+              </a:ext>
+            </a:extLst>
+          </p:cNvPr>
+          <p:cNvPicPr>
+            <a:picLocks noChangeAspect="1"/>
+          </p:cNvPicPr>
+          <p:nvPr/>
+        </p:nvPicPr>
+        <p:blipFill>
+          <a:blip r:embed="rId2"/>
+          <a:stretch>
+            <a:fillRect/>
+          </a:stretch>
+        </p:blipFill>
+        <p:spPr>
+          <a:xfrm>
+            <a:off x="4512639" y="1666371"/>
+            <a:ext cx="4469043" cy="3026698"/>
+          </a:xfrm>
+          <a:prstGeom prst="rect">
+            <a:avLst/>
+          </a:prstGeom>
+        </p:spPr>
+      </p:pic>
+    </p:spTree>
+    <p:extLst>
+      <p:ext uri="{BB962C8B-B14F-4D97-AF65-F5344CB8AC3E}">
+        <p14:creationId xmlns:p14="http://schemas.microsoft.com/office/powerpoint/2010/main" val="3678721740"/>
+      </p:ext>
+    </p:extLst>
+  </p:cSld>
+  <p:clrMapOvr>
+    <a:masterClrMapping/>
+  </p:clrMapOvr>
+</p:sld>
+</file>
+
+<file path=ppt/slides/slide73.xml><?xml version="1.0" encoding="utf-8"?>
+<p:sld xmlns:a="http://schemas.openxmlformats.org/drawingml/2006/main" xmlns:r="http://schemas.openxmlformats.org/officeDocument/2006/relationships" xmlns:p="http://schemas.openxmlformats.org/presentationml/2006/main">
+  <p:cSld>
+    <p:spTree>
+      <p:nvGrpSpPr>
+        <p:cNvPr id="1" name="">
+          <a:extLst>
+            <a:ext uri="{FF2B5EF4-FFF2-40B4-BE49-F238E27FC236}">
+              <a16:creationId xmlns:a16="http://schemas.microsoft.com/office/drawing/2014/main" id="{AA75778F-09DD-FFFC-15F5-F74D0C1FF0D2}"/>
+            </a:ext>
+          </a:extLst>
+        </p:cNvPr>
+        <p:cNvGrpSpPr/>
+        <p:nvPr/>
+      </p:nvGrpSpPr>
+      <p:grpSpPr>
+        <a:xfrm>
+          <a:off x="0" y="0"/>
+          <a:ext cx="0" cy="0"/>
+          <a:chOff x="0" y="0"/>
+          <a:chExt cx="0" cy="0"/>
+        </a:xfrm>
+      </p:grpSpPr>
+      <p:sp>
+        <p:nvSpPr>
+          <p:cNvPr id="2" name="Title 1">
+            <a:extLst>
+              <a:ext uri="{FF2B5EF4-FFF2-40B4-BE49-F238E27FC236}">
+                <a16:creationId xmlns:a16="http://schemas.microsoft.com/office/drawing/2014/main" id="{A84A741E-04F8-FEF4-B8A1-314DA00DBCC9}"/>
+              </a:ext>
+            </a:extLst>
+          </p:cNvPr>
+          <p:cNvSpPr>
+            <a:spLocks noGrp="1"/>
+          </p:cNvSpPr>
+          <p:nvPr>
+            <p:ph type="title"/>
+          </p:nvPr>
+        </p:nvSpPr>
+        <p:spPr/>
+        <p:txBody>
+          <a:bodyPr/>
+          <a:lstStyle/>
+          <a:p>
+            <a:pPr marL="0" lvl="0" indent="0">
+              <a:buNone/>
+            </a:pPr>
+            <a:r>
+              <a:rPr lang="en-US" dirty="0"/>
+              <a:t>Imputation of Missing Values</a:t>
+            </a:r>
+            <a:endParaRPr dirty="0"/>
+          </a:p>
+        </p:txBody>
+      </p:sp>
+      <p:sp>
+        <p:nvSpPr>
+          <p:cNvPr id="3" name="Content Placeholder 2">
+            <a:extLst>
+              <a:ext uri="{FF2B5EF4-FFF2-40B4-BE49-F238E27FC236}">
+                <a16:creationId xmlns:a16="http://schemas.microsoft.com/office/drawing/2014/main" id="{94EEE77B-4365-0FA5-6DB3-6DCFF70501D1}"/>
+              </a:ext>
+            </a:extLst>
+          </p:cNvPr>
+          <p:cNvSpPr>
+            <a:spLocks noGrp="1"/>
+          </p:cNvSpPr>
+          <p:nvPr>
+            <p:ph idx="1"/>
+          </p:nvPr>
+        </p:nvSpPr>
+        <p:spPr>
+          <a:xfrm>
+            <a:off x="457200" y="1200151"/>
+            <a:ext cx="8229600" cy="3737370"/>
+          </a:xfrm>
+        </p:spPr>
+        <p:txBody>
+          <a:bodyPr>
+            <a:normAutofit/>
+          </a:bodyPr>
+          <a:lstStyle/>
+          <a:p>
+            <a:pPr marL="0" indent="0">
+              <a:buNone/>
+            </a:pPr>
+            <a:r>
+              <a:rPr lang="en-US" dirty="0"/>
+              <a:t>For further reading: </a:t>
+            </a:r>
+          </a:p>
+          <a:p>
+            <a:r>
+              <a:rPr lang="en-US" dirty="0"/>
+              <a:t>For a detailed discussion of imputation with the MICE algorithm see </a:t>
+            </a:r>
+            <a:r>
+              <a:rPr lang="en-US" dirty="0">
+                <a:hlinkClick r:id="rId2"/>
+              </a:rPr>
+              <a:t>Flexible Imputation of Missing Data, Second Edition, Stef van Buuren, Chapman and Hall, 2018</a:t>
+            </a:r>
+            <a:endParaRPr lang="en-US" dirty="0"/>
+          </a:p>
+          <a:p>
+            <a:r>
+              <a:rPr lang="en-US" dirty="0"/>
+              <a:t>For a broad and deep exploration of working with missing data see </a:t>
+            </a:r>
+            <a:r>
+              <a:rPr lang="en-US" dirty="0">
+                <a:hlinkClick r:id="rId3"/>
+              </a:rPr>
+              <a:t>Statistical Analysis with Missing Data, Little and Rudin, Wiley, 2020</a:t>
+            </a:r>
+            <a:endParaRPr lang="en-US" dirty="0"/>
+          </a:p>
+          <a:p>
+            <a:endParaRPr lang="en-US" dirty="0"/>
+          </a:p>
+        </p:txBody>
+      </p:sp>
+    </p:spTree>
+    <p:extLst>
+      <p:ext uri="{BB962C8B-B14F-4D97-AF65-F5344CB8AC3E}">
+        <p14:creationId xmlns:p14="http://schemas.microsoft.com/office/powerpoint/2010/main" val="1504276749"/>
+      </p:ext>
+    </p:extLst>
+  </p:cSld>
+  <p:clrMapOvr>
+    <a:masterClrMapping/>
+  </p:clrMapOvr>
+</p:sld>
+</file>
+
+<file path=ppt/slides/slide74.xml><?xml version="1.0" encoding="utf-8"?>
 <p:sld xmlns:a="http://schemas.openxmlformats.org/drawingml/2006/main" xmlns:r="http://schemas.openxmlformats.org/officeDocument/2006/relationships" xmlns:p="http://schemas.openxmlformats.org/presentationml/2006/main">
   <p:cSld>
     <p:spTree>
@@ -34289,7 +36510,7 @@
 </p:sld>
 </file>
 
-<file path=ppt/slides/slide68.xml><?xml version="1.0" encoding="utf-8"?>
+<file path=ppt/slides/slide75.xml><?xml version="1.0" encoding="utf-8"?>
 <p:sld xmlns:a="http://schemas.openxmlformats.org/drawingml/2006/main" xmlns:r="http://schemas.openxmlformats.org/officeDocument/2006/relationships" xmlns:p="http://schemas.openxmlformats.org/presentationml/2006/main">
   <p:cSld>
     <p:spTree>
@@ -34484,385 +36705,6 @@
   <p:clrMapOvr>
     <a:masterClrMapping/>
   </p:clrMapOvr>
-</p:sld>
-</file>
-
-<file path=ppt/slides/slide7.xml><?xml version="1.0" encoding="utf-8"?>
-<p:sld xmlns:a="http://schemas.openxmlformats.org/drawingml/2006/main" xmlns:r="http://schemas.openxmlformats.org/officeDocument/2006/relationships" xmlns:p="http://schemas.openxmlformats.org/presentationml/2006/main">
-  <p:cSld>
-    <p:spTree>
-      <p:nvGrpSpPr>
-        <p:cNvPr id="1" name="">
-          <a:extLst>
-            <a:ext uri="{FF2B5EF4-FFF2-40B4-BE49-F238E27FC236}">
-              <a16:creationId xmlns:a16="http://schemas.microsoft.com/office/drawing/2014/main" id="{B3993F59-9009-4191-4BD0-62EAFBE3087E}"/>
-            </a:ext>
-          </a:extLst>
-        </p:cNvPr>
-        <p:cNvGrpSpPr/>
-        <p:nvPr/>
-      </p:nvGrpSpPr>
-      <p:grpSpPr>
-        <a:xfrm>
-          <a:off x="0" y="0"/>
-          <a:ext cx="0" cy="0"/>
-          <a:chOff x="0" y="0"/>
-          <a:chExt cx="0" cy="0"/>
-        </a:xfrm>
-      </p:grpSpPr>
-      <p:sp>
-        <p:nvSpPr>
-          <p:cNvPr id="2" name="Title 1">
-            <a:extLst>
-              <a:ext uri="{FF2B5EF4-FFF2-40B4-BE49-F238E27FC236}">
-                <a16:creationId xmlns:a16="http://schemas.microsoft.com/office/drawing/2014/main" id="{5A5D5B7B-EC31-F645-671E-3F2116407953}"/>
-              </a:ext>
-            </a:extLst>
-          </p:cNvPr>
-          <p:cNvSpPr>
-            <a:spLocks noGrp="1"/>
-          </p:cNvSpPr>
-          <p:nvPr>
-            <p:ph type="title"/>
-          </p:nvPr>
-        </p:nvSpPr>
-        <p:spPr/>
-        <p:txBody>
-          <a:bodyPr/>
-          <a:lstStyle/>
-          <a:p>
-            <a:pPr marL="0" lvl="0" indent="0">
-              <a:buNone/>
-            </a:pPr>
-            <a:r>
-              <a:rPr lang="en-US" dirty="0"/>
-              <a:t>Modeling Zero-Inflated Distributions</a:t>
-            </a:r>
-            <a:endParaRPr dirty="0"/>
-          </a:p>
-        </p:txBody>
-      </p:sp>
-      <p:sp>
-        <p:nvSpPr>
-          <p:cNvPr id="3" name="Content Placeholder 2">
-            <a:extLst>
-              <a:ext uri="{FF2B5EF4-FFF2-40B4-BE49-F238E27FC236}">
-                <a16:creationId xmlns:a16="http://schemas.microsoft.com/office/drawing/2014/main" id="{4C4AB32E-A8D9-3191-4BF8-4C76B8CCB7FC}"/>
-              </a:ext>
-            </a:extLst>
-          </p:cNvPr>
-          <p:cNvSpPr>
-            <a:spLocks noGrp="1"/>
-          </p:cNvSpPr>
-          <p:nvPr>
-            <p:ph idx="1"/>
-          </p:nvPr>
-        </p:nvSpPr>
-        <p:spPr/>
-        <p:txBody>
-          <a:bodyPr>
-            <a:normAutofit/>
-          </a:bodyPr>
-          <a:lstStyle/>
-          <a:p>
-            <a:pPr marL="0" lvl="0" indent="0">
-              <a:buNone/>
-            </a:pPr>
-            <a:r>
-              <a:rPr lang="en-US" dirty="0"/>
-              <a:t>How can we model zero inflated distributions?  </a:t>
-            </a:r>
-            <a:endParaRPr dirty="0"/>
-          </a:p>
-          <a:p>
-            <a:pPr lvl="0"/>
-            <a:r>
-              <a:rPr lang="en-US" dirty="0"/>
-              <a:t>Standard ‘named’ distributions do not account for zero-inflation  </a:t>
-            </a:r>
-          </a:p>
-          <a:p>
-            <a:pPr lvl="0"/>
-            <a:r>
-              <a:rPr lang="en-US" dirty="0"/>
-              <a:t>Can use a mixture of two distributions  </a:t>
-            </a:r>
-          </a:p>
-          <a:p>
-            <a:pPr lvl="1"/>
-            <a:r>
-              <a:rPr lang="en-US" dirty="0"/>
-              <a:t>A binomial distribution, or switching distribution  </a:t>
-            </a:r>
-          </a:p>
-          <a:p>
-            <a:pPr lvl="1"/>
-            <a:r>
-              <a:rPr lang="en-US" dirty="0"/>
-              <a:t>A standard distribution </a:t>
-            </a:r>
-          </a:p>
-          <a:p>
-            <a:r>
-              <a:rPr lang="en-US" dirty="0"/>
-              <a:t>The binomial distribution serves as a ‘switch’ between 0 response and the other distribution   </a:t>
-            </a:r>
-          </a:p>
-          <a:p>
-            <a:pPr lvl="0"/>
-            <a:endParaRPr dirty="0"/>
-          </a:p>
-        </p:txBody>
-      </p:sp>
-    </p:spTree>
-    <p:extLst>
-      <p:ext uri="{BB962C8B-B14F-4D97-AF65-F5344CB8AC3E}">
-        <p14:creationId xmlns:p14="http://schemas.microsoft.com/office/powerpoint/2010/main" val="4064511800"/>
-      </p:ext>
-    </p:extLst>
-  </p:cSld>
-  <p:clrMapOvr>
-    <a:masterClrMapping/>
-  </p:clrMapOvr>
-  <p:timing>
-    <p:tnLst>
-      <p:par>
-        <p:cTn id="1" dur="indefinite" restart="never" nodeType="tmRoot">
-          <p:childTnLst>
-            <p:seq concurrent="1" nextAc="seek">
-              <p:cTn id="2" dur="indefinite" nodeType="mainSeq">
-                <p:childTnLst>
-                  <p:par>
-                    <p:cTn id="3" fill="hold">
-                      <p:stCondLst>
-                        <p:cond delay="indefinite"/>
-                      </p:stCondLst>
-                      <p:childTnLst>
-                        <p:par>
-                          <p:cTn id="4" fill="hold">
-                            <p:stCondLst>
-                              <p:cond delay="0"/>
-                            </p:stCondLst>
-                            <p:childTnLst>
-                              <p:par>
-                                <p:cTn id="5" presetID="1" presetClass="entr" presetSubtype="0" fill="hold" nodeType="clickEffect">
-                                  <p:stCondLst>
-                                    <p:cond delay="0"/>
-                                  </p:stCondLst>
-                                  <p:childTnLst>
-                                    <p:set>
-                                      <p:cBhvr>
-                                        <p:cTn id="6" dur="1" fill="hold">
-                                          <p:stCondLst>
-                                            <p:cond delay="0"/>
-                                          </p:stCondLst>
-                                        </p:cTn>
-                                        <p:tgtEl>
-                                          <p:spTgt spid="3">
-                                            <p:txEl>
-                                              <p:pRg st="1" end="1"/>
-                                            </p:txEl>
-                                          </p:spTgt>
-                                        </p:tgtEl>
-                                        <p:attrNameLst>
-                                          <p:attrName>style.visibility</p:attrName>
-                                        </p:attrNameLst>
-                                      </p:cBhvr>
-                                      <p:to>
-                                        <p:strVal val="visible"/>
-                                      </p:to>
-                                    </p:set>
-                                  </p:childTnLst>
-                                </p:cTn>
-                              </p:par>
-                            </p:childTnLst>
-                          </p:cTn>
-                        </p:par>
-                      </p:childTnLst>
-                    </p:cTn>
-                  </p:par>
-                  <p:par>
-                    <p:cTn id="7" fill="hold">
-                      <p:stCondLst>
-                        <p:cond delay="indefinite"/>
-                      </p:stCondLst>
-                      <p:childTnLst>
-                        <p:par>
-                          <p:cTn id="8" fill="hold">
-                            <p:stCondLst>
-                              <p:cond delay="0"/>
-                            </p:stCondLst>
-                            <p:childTnLst>
-                              <p:par>
-                                <p:cTn id="9" presetID="1" presetClass="entr" presetSubtype="0" fill="hold" nodeType="clickEffect">
-                                  <p:stCondLst>
-                                    <p:cond delay="0"/>
-                                  </p:stCondLst>
-                                  <p:childTnLst>
-                                    <p:set>
-                                      <p:cBhvr>
-                                        <p:cTn id="10" dur="1" fill="hold">
-                                          <p:stCondLst>
-                                            <p:cond delay="0"/>
-                                          </p:stCondLst>
-                                        </p:cTn>
-                                        <p:tgtEl>
-                                          <p:spTgt spid="3">
-                                            <p:txEl>
-                                              <p:pRg st="2" end="2"/>
-                                            </p:txEl>
-                                          </p:spTgt>
-                                        </p:tgtEl>
-                                        <p:attrNameLst>
-                                          <p:attrName>style.visibility</p:attrName>
-                                        </p:attrNameLst>
-                                      </p:cBhvr>
-                                      <p:to>
-                                        <p:strVal val="visible"/>
-                                      </p:to>
-                                    </p:set>
-                                  </p:childTnLst>
-                                </p:cTn>
-                              </p:par>
-                              <p:par>
-                                <p:cTn id="11" presetID="1" presetClass="entr" presetSubtype="0" fill="hold" nodeType="withEffect">
-                                  <p:stCondLst>
-                                    <p:cond delay="0"/>
-                                  </p:stCondLst>
-                                  <p:childTnLst>
-                                    <p:set>
-                                      <p:cBhvr>
-                                        <p:cTn id="12" dur="1" fill="hold">
-                                          <p:stCondLst>
-                                            <p:cond delay="0"/>
-                                          </p:stCondLst>
-                                        </p:cTn>
-                                        <p:tgtEl>
-                                          <p:spTgt spid="3">
-                                            <p:txEl>
-                                              <p:pRg st="3" end="3"/>
-                                            </p:txEl>
-                                          </p:spTgt>
-                                        </p:tgtEl>
-                                        <p:attrNameLst>
-                                          <p:attrName>style.visibility</p:attrName>
-                                        </p:attrNameLst>
-                                      </p:cBhvr>
-                                      <p:to>
-                                        <p:strVal val="visible"/>
-                                      </p:to>
-                                    </p:set>
-                                  </p:childTnLst>
-                                </p:cTn>
-                              </p:par>
-                              <p:par>
-                                <p:cTn id="13" presetID="1" presetClass="entr" presetSubtype="0" fill="hold" nodeType="withEffect">
-                                  <p:stCondLst>
-                                    <p:cond delay="0"/>
-                                  </p:stCondLst>
-                                  <p:childTnLst>
-                                    <p:set>
-                                      <p:cBhvr>
-                                        <p:cTn id="14" dur="1" fill="hold">
-                                          <p:stCondLst>
-                                            <p:cond delay="0"/>
-                                          </p:stCondLst>
-                                        </p:cTn>
-                                        <p:tgtEl>
-                                          <p:spTgt spid="3">
-                                            <p:txEl>
-                                              <p:pRg st="4" end="4"/>
-                                            </p:txEl>
-                                          </p:spTgt>
-                                        </p:tgtEl>
-                                        <p:attrNameLst>
-                                          <p:attrName>style.visibility</p:attrName>
-                                        </p:attrNameLst>
-                                      </p:cBhvr>
-                                      <p:to>
-                                        <p:strVal val="visible"/>
-                                      </p:to>
-                                    </p:set>
-                                  </p:childTnLst>
-                                </p:cTn>
-                              </p:par>
-                            </p:childTnLst>
-                          </p:cTn>
-                        </p:par>
-                      </p:childTnLst>
-                    </p:cTn>
-                  </p:par>
-                  <p:par>
-                    <p:cTn id="15" fill="hold">
-                      <p:stCondLst>
-                        <p:cond delay="indefinite"/>
-                      </p:stCondLst>
-                      <p:childTnLst>
-                        <p:par>
-                          <p:cTn id="16" fill="hold">
-                            <p:stCondLst>
-                              <p:cond delay="0"/>
-                            </p:stCondLst>
-                            <p:childTnLst>
-                              <p:par>
-                                <p:cTn id="17" presetID="1" presetClass="entr" presetSubtype="0" fill="hold" nodeType="clickEffect">
-                                  <p:stCondLst>
-                                    <p:cond delay="0"/>
-                                  </p:stCondLst>
-                                  <p:childTnLst>
-                                    <p:set>
-                                      <p:cBhvr>
-                                        <p:cTn id="18" dur="1" fill="hold">
-                                          <p:stCondLst>
-                                            <p:cond delay="0"/>
-                                          </p:stCondLst>
-                                        </p:cTn>
-                                        <p:tgtEl>
-                                          <p:spTgt spid="3">
-                                            <p:txEl>
-                                              <p:pRg st="5" end="5"/>
-                                            </p:txEl>
-                                          </p:spTgt>
-                                        </p:tgtEl>
-                                        <p:attrNameLst>
-                                          <p:attrName>style.visibility</p:attrName>
-                                        </p:attrNameLst>
-                                      </p:cBhvr>
-                                      <p:to>
-                                        <p:strVal val="visible"/>
-                                      </p:to>
-                                    </p:set>
-                                  </p:childTnLst>
-                                </p:cTn>
-                              </p:par>
-                            </p:childTnLst>
-                          </p:cTn>
-                        </p:par>
-                      </p:childTnLst>
-                    </p:cTn>
-                  </p:par>
-                </p:childTnLst>
-              </p:cTn>
-              <p:prevCondLst>
-                <p:cond evt="onPrev" delay="0">
-                  <p:tgtEl>
-                    <p:sldTgt/>
-                  </p:tgtEl>
-                </p:cond>
-              </p:prevCondLst>
-              <p:nextCondLst>
-                <p:cond evt="onNext" delay="0">
-                  <p:tgtEl>
-                    <p:sldTgt/>
-                  </p:tgtEl>
-                </p:cond>
-              </p:nextCondLst>
-            </p:seq>
-          </p:childTnLst>
-        </p:cTn>
-      </p:par>
-    </p:tnLst>
-  </p:timing>
 </p:sld>
 </file>
 

</xml_diff>

<commit_message>
Typo corrections from lecture
</commit_message>
<xml_diff>
--- a/LectureSlides/11_ModelsForMessyData.pptx
+++ b/LectureSlides/11_ModelsForMessyData.pptx
@@ -7158,7 +7158,7 @@
             <a:pPr lvl="0"/>
             <a:r>
               <a:rPr lang="en-US" dirty="0"/>
-              <a:t>Sightings of heard and flock animals seen at a location can have large numbers at some times</a:t>
+              <a:t>Sightings of herd and flock animals seen at a location can have large numbers at some times</a:t>
             </a:r>
           </a:p>
           <a:p>
@@ -8226,7 +8226,7 @@
             <a:pPr lvl="1"/>
             <a:r>
               <a:rPr lang="en-US" dirty="0"/>
-              <a:t>Imputation methods must preserve distributions to be valid for influence   </a:t>
+              <a:t>Imputation methods must preserve distributions to be valid for inference   </a:t>
             </a:r>
           </a:p>
           <a:p>
@@ -36003,7 +36003,7 @@
               <a:rPr lang="en-US" b="1" dirty="0">
                 <a:hlinkClick r:id="rId2"/>
               </a:rPr>
-              <a:t>The Multivariate Imputation by Chained Equations (MICE) </a:t>
+              <a:t>The Multiple Imputation by Chained Equations (MICE) </a:t>
             </a:r>
             <a:r>
               <a:rPr lang="en-US" dirty="0"/>
@@ -36280,7 +36280,7 @@
               <a:rPr lang="en-US" b="1" dirty="0">
                 <a:hlinkClick r:id="rId2"/>
               </a:rPr>
-              <a:t>The Multivariate Imputation by Chained Equations (MICE) </a:t>
+              <a:t>The Multiple Imputation by Chained Equations (MICE) </a:t>
             </a:r>
             <a:r>
               <a:rPr lang="en-US" dirty="0"/>
@@ -36438,7 +36438,7 @@
               <a:rPr lang="en-US" b="1" dirty="0">
                 <a:hlinkClick r:id="rId2"/>
               </a:rPr>
-              <a:t>The Multivariate Imputation by Chained Equations (MICE) </a:t>
+              <a:t>The Multiple Imputation by Chained Equations (MICE) </a:t>
             </a:r>
             <a:r>
               <a:rPr lang="en-US" dirty="0"/>
@@ -36567,7 +36567,7 @@
               <a:rPr lang="en-US" b="1" dirty="0">
                 <a:hlinkClick r:id="rId2"/>
               </a:rPr>
-              <a:t>The Multivariate Imputation by Chained Equations (MICE) </a:t>
+              <a:t>The Multiple Imputation by Chained Equations (MICE) </a:t>
             </a:r>
             <a:r>
               <a:rPr lang="en-US" dirty="0"/>
@@ -36715,7 +36715,7 @@
               <a:rPr lang="en-US" b="1" dirty="0">
                 <a:hlinkClick r:id="rId2"/>
               </a:rPr>
-              <a:t>The Multivariate Imputation by Chained Equations (MICE) </a:t>
+              <a:t>The Multiple Imputation by Chained Equations (MICE) </a:t>
             </a:r>
             <a:r>
               <a:rPr lang="en-US" dirty="0"/>
@@ -40823,11 +40823,7 @@
               <a:p>
                 <a:r>
                   <a:rPr lang="en-US" dirty="0"/>
-                  <a:t>MICE is not effective for </a:t>
-                </a:r>
-                <a:r>
-                  <a:rPr lang="en-US"/>
-                  <a:t>missing percent of about </a:t>
+                  <a:t>MICE is not effective for missing percent of about </a:t>
                 </a:r>
                 <a14:m>
                   <m:oMath xmlns:m="http://schemas.openxmlformats.org/officeDocument/2006/math">
@@ -40931,6 +40927,330 @@
   <p:clrMapOvr>
     <a:masterClrMapping/>
   </p:clrMapOvr>
+  <p:timing>
+    <p:tnLst>
+      <p:par>
+        <p:cTn id="1" dur="indefinite" restart="never" nodeType="tmRoot">
+          <p:childTnLst>
+            <p:seq concurrent="1" nextAc="seek">
+              <p:cTn id="2" dur="indefinite" nodeType="mainSeq">
+                <p:childTnLst>
+                  <p:par>
+                    <p:cTn id="3" fill="hold">
+                      <p:stCondLst>
+                        <p:cond delay="indefinite"/>
+                      </p:stCondLst>
+                      <p:childTnLst>
+                        <p:par>
+                          <p:cTn id="4" fill="hold">
+                            <p:stCondLst>
+                              <p:cond delay="0"/>
+                            </p:stCondLst>
+                            <p:childTnLst>
+                              <p:par>
+                                <p:cTn id="5" presetID="1" presetClass="entr" presetSubtype="0" fill="hold" nodeType="clickEffect">
+                                  <p:stCondLst>
+                                    <p:cond delay="0"/>
+                                  </p:stCondLst>
+                                  <p:childTnLst>
+                                    <p:set>
+                                      <p:cBhvr>
+                                        <p:cTn id="6" dur="1" fill="hold">
+                                          <p:stCondLst>
+                                            <p:cond delay="0"/>
+                                          </p:stCondLst>
+                                        </p:cTn>
+                                        <p:tgtEl>
+                                          <p:spTgt spid="3">
+                                            <p:txEl>
+                                              <p:pRg st="1" end="1"/>
+                                            </p:txEl>
+                                          </p:spTgt>
+                                        </p:tgtEl>
+                                        <p:attrNameLst>
+                                          <p:attrName>style.visibility</p:attrName>
+                                        </p:attrNameLst>
+                                      </p:cBhvr>
+                                      <p:to>
+                                        <p:strVal val="visible"/>
+                                      </p:to>
+                                    </p:set>
+                                  </p:childTnLst>
+                                </p:cTn>
+                              </p:par>
+                            </p:childTnLst>
+                          </p:cTn>
+                        </p:par>
+                      </p:childTnLst>
+                    </p:cTn>
+                  </p:par>
+                  <p:par>
+                    <p:cTn id="7" fill="hold">
+                      <p:stCondLst>
+                        <p:cond delay="indefinite"/>
+                      </p:stCondLst>
+                      <p:childTnLst>
+                        <p:par>
+                          <p:cTn id="8" fill="hold">
+                            <p:stCondLst>
+                              <p:cond delay="0"/>
+                            </p:stCondLst>
+                            <p:childTnLst>
+                              <p:par>
+                                <p:cTn id="9" presetID="1" presetClass="entr" presetSubtype="0" fill="hold" nodeType="clickEffect">
+                                  <p:stCondLst>
+                                    <p:cond delay="0"/>
+                                  </p:stCondLst>
+                                  <p:childTnLst>
+                                    <p:set>
+                                      <p:cBhvr>
+                                        <p:cTn id="10" dur="1" fill="hold">
+                                          <p:stCondLst>
+                                            <p:cond delay="0"/>
+                                          </p:stCondLst>
+                                        </p:cTn>
+                                        <p:tgtEl>
+                                          <p:spTgt spid="3">
+                                            <p:txEl>
+                                              <p:pRg st="2" end="2"/>
+                                            </p:txEl>
+                                          </p:spTgt>
+                                        </p:tgtEl>
+                                        <p:attrNameLst>
+                                          <p:attrName>style.visibility</p:attrName>
+                                        </p:attrNameLst>
+                                      </p:cBhvr>
+                                      <p:to>
+                                        <p:strVal val="visible"/>
+                                      </p:to>
+                                    </p:set>
+                                  </p:childTnLst>
+                                </p:cTn>
+                              </p:par>
+                            </p:childTnLst>
+                          </p:cTn>
+                        </p:par>
+                      </p:childTnLst>
+                    </p:cTn>
+                  </p:par>
+                  <p:par>
+                    <p:cTn id="11" fill="hold">
+                      <p:stCondLst>
+                        <p:cond delay="indefinite"/>
+                      </p:stCondLst>
+                      <p:childTnLst>
+                        <p:par>
+                          <p:cTn id="12" fill="hold">
+                            <p:stCondLst>
+                              <p:cond delay="0"/>
+                            </p:stCondLst>
+                            <p:childTnLst>
+                              <p:par>
+                                <p:cTn id="13" presetID="1" presetClass="entr" presetSubtype="0" fill="hold" nodeType="clickEffect">
+                                  <p:stCondLst>
+                                    <p:cond delay="0"/>
+                                  </p:stCondLst>
+                                  <p:childTnLst>
+                                    <p:set>
+                                      <p:cBhvr>
+                                        <p:cTn id="14" dur="1" fill="hold">
+                                          <p:stCondLst>
+                                            <p:cond delay="0"/>
+                                          </p:stCondLst>
+                                        </p:cTn>
+                                        <p:tgtEl>
+                                          <p:spTgt spid="3">
+                                            <p:txEl>
+                                              <p:pRg st="3" end="3"/>
+                                            </p:txEl>
+                                          </p:spTgt>
+                                        </p:tgtEl>
+                                        <p:attrNameLst>
+                                          <p:attrName>style.visibility</p:attrName>
+                                        </p:attrNameLst>
+                                      </p:cBhvr>
+                                      <p:to>
+                                        <p:strVal val="visible"/>
+                                      </p:to>
+                                    </p:set>
+                                  </p:childTnLst>
+                                </p:cTn>
+                              </p:par>
+                            </p:childTnLst>
+                          </p:cTn>
+                        </p:par>
+                      </p:childTnLst>
+                    </p:cTn>
+                  </p:par>
+                  <p:par>
+                    <p:cTn id="15" fill="hold">
+                      <p:stCondLst>
+                        <p:cond delay="indefinite"/>
+                      </p:stCondLst>
+                      <p:childTnLst>
+                        <p:par>
+                          <p:cTn id="16" fill="hold">
+                            <p:stCondLst>
+                              <p:cond delay="0"/>
+                            </p:stCondLst>
+                            <p:childTnLst>
+                              <p:par>
+                                <p:cTn id="17" presetID="1" presetClass="entr" presetSubtype="0" fill="hold" nodeType="clickEffect">
+                                  <p:stCondLst>
+                                    <p:cond delay="0"/>
+                                  </p:stCondLst>
+                                  <p:childTnLst>
+                                    <p:set>
+                                      <p:cBhvr>
+                                        <p:cTn id="18" dur="1" fill="hold">
+                                          <p:stCondLst>
+                                            <p:cond delay="0"/>
+                                          </p:stCondLst>
+                                        </p:cTn>
+                                        <p:tgtEl>
+                                          <p:spTgt spid="3">
+                                            <p:txEl>
+                                              <p:pRg st="4" end="4"/>
+                                            </p:txEl>
+                                          </p:spTgt>
+                                        </p:tgtEl>
+                                        <p:attrNameLst>
+                                          <p:attrName>style.visibility</p:attrName>
+                                        </p:attrNameLst>
+                                      </p:cBhvr>
+                                      <p:to>
+                                        <p:strVal val="visible"/>
+                                      </p:to>
+                                    </p:set>
+                                  </p:childTnLst>
+                                </p:cTn>
+                              </p:par>
+                            </p:childTnLst>
+                          </p:cTn>
+                        </p:par>
+                      </p:childTnLst>
+                    </p:cTn>
+                  </p:par>
+                  <p:par>
+                    <p:cTn id="19" fill="hold">
+                      <p:stCondLst>
+                        <p:cond delay="indefinite"/>
+                      </p:stCondLst>
+                      <p:childTnLst>
+                        <p:par>
+                          <p:cTn id="20" fill="hold">
+                            <p:stCondLst>
+                              <p:cond delay="0"/>
+                            </p:stCondLst>
+                            <p:childTnLst>
+                              <p:par>
+                                <p:cTn id="21" presetID="1" presetClass="entr" presetSubtype="0" fill="hold" nodeType="clickEffect">
+                                  <p:stCondLst>
+                                    <p:cond delay="0"/>
+                                  </p:stCondLst>
+                                  <p:childTnLst>
+                                    <p:set>
+                                      <p:cBhvr>
+                                        <p:cTn id="22" dur="1" fill="hold">
+                                          <p:stCondLst>
+                                            <p:cond delay="0"/>
+                                          </p:stCondLst>
+                                        </p:cTn>
+                                        <p:tgtEl>
+                                          <p:spTgt spid="3">
+                                            <p:txEl>
+                                              <p:pRg st="5" end="5"/>
+                                            </p:txEl>
+                                          </p:spTgt>
+                                        </p:tgtEl>
+                                        <p:attrNameLst>
+                                          <p:attrName>style.visibility</p:attrName>
+                                        </p:attrNameLst>
+                                      </p:cBhvr>
+                                      <p:to>
+                                        <p:strVal val="visible"/>
+                                      </p:to>
+                                    </p:set>
+                                  </p:childTnLst>
+                                </p:cTn>
+                              </p:par>
+                            </p:childTnLst>
+                          </p:cTn>
+                        </p:par>
+                      </p:childTnLst>
+                    </p:cTn>
+                  </p:par>
+                  <p:par>
+                    <p:cTn id="23" fill="hold">
+                      <p:stCondLst>
+                        <p:cond delay="indefinite"/>
+                      </p:stCondLst>
+                      <p:childTnLst>
+                        <p:par>
+                          <p:cTn id="24" fill="hold">
+                            <p:stCondLst>
+                              <p:cond delay="0"/>
+                            </p:stCondLst>
+                            <p:childTnLst>
+                              <p:par>
+                                <p:cTn id="25" presetID="1" presetClass="entr" presetSubtype="0" fill="hold" nodeType="clickEffect">
+                                  <p:stCondLst>
+                                    <p:cond delay="0"/>
+                                  </p:stCondLst>
+                                  <p:childTnLst>
+                                    <p:set>
+                                      <p:cBhvr>
+                                        <p:cTn id="26" dur="1" fill="hold">
+                                          <p:stCondLst>
+                                            <p:cond delay="0"/>
+                                          </p:stCondLst>
+                                        </p:cTn>
+                                        <p:tgtEl>
+                                          <p:spTgt spid="3">
+                                            <p:txEl>
+                                              <p:pRg st="6" end="6"/>
+                                            </p:txEl>
+                                          </p:spTgt>
+                                        </p:tgtEl>
+                                        <p:attrNameLst>
+                                          <p:attrName>style.visibility</p:attrName>
+                                        </p:attrNameLst>
+                                      </p:cBhvr>
+                                      <p:to>
+                                        <p:strVal val="visible"/>
+                                      </p:to>
+                                    </p:set>
+                                  </p:childTnLst>
+                                </p:cTn>
+                              </p:par>
+                            </p:childTnLst>
+                          </p:cTn>
+                        </p:par>
+                      </p:childTnLst>
+                    </p:cTn>
+                  </p:par>
+                </p:childTnLst>
+              </p:cTn>
+              <p:prevCondLst>
+                <p:cond evt="onPrev" delay="0">
+                  <p:tgtEl>
+                    <p:sldTgt/>
+                  </p:tgtEl>
+                </p:cond>
+              </p:prevCondLst>
+              <p:nextCondLst>
+                <p:cond evt="onNext" delay="0">
+                  <p:tgtEl>
+                    <p:sldTgt/>
+                  </p:tgtEl>
+                </p:cond>
+              </p:nextCondLst>
+            </p:seq>
+          </p:childTnLst>
+        </p:cTn>
+      </p:par>
+    </p:tnLst>
+  </p:timing>
 </p:sld>
 </file>
 

</xml_diff>